<commit_message>
Sesiones 4 y 5: las prácticas migran a Copilot Chat con archivos adjuntos
- Práctica B de la sesión 4 ya no depende de Copilot dentro de Excel: se
  hace en Copilot Chat con los tres documentos adjuntos y la tabla se pega
  en la plantilla. Prácticas A y C indican el flujo de adjuntar en el chat.
- El RAG institucional de la sesión 5 se ancla a OneDrive (comprobado) en
  lugar de SharePoint, con nota para verificar SharePoint por área.
- Handouts 4 y 5 actualizados en los mismos puntos.

Co-Authored-By: Claude Fable 5 <noreply@anthropic.com>
</commit_message>
<xml_diff>
--- a/sesion-04/Sesion_04_PLN_Gestion_Documental.pptx
+++ b/sesion-04/Sesion_04_PLN_Gestion_Documental.pptx
@@ -4190,7 +4190,7 @@
                 <a:ea typeface="Calibri" pitchFamily="34" charset="-122"/>
                 <a:cs typeface="Calibri" pitchFamily="34" charset="-120"/>
               </a:rPr>
-              <a:t>Archivo: Registros_atencion_ciudadana_PARTICIPANTE.xlsx, hoja Registros.</a:t>
+              <a:t>Archivo: Registros_atencion_ciudadana_PARTICIPANTE.xlsx, hoja Registros. Súbelo a OneDrive y adjúntalo en Copilot Chat; si no lee la hoja, pega los registros directo.</a:t>
             </a:r>
             <a:endParaRPr lang="en-US" sz="1350" dirty="0"/>
           </a:p>
@@ -9474,7 +9474,7 @@
                 <a:ea typeface="Calibri" pitchFamily="34" charset="-122"/>
                 <a:cs typeface="Calibri" pitchFamily="34" charset="-120"/>
               </a:rPr>
-              <a:t>Toma un informe de evaluación público y pide la síntesis extractiva. Dile expresamente que transcriba oraciones textuales sin reescribirlas, y que las ponga entre comillas.</a:t>
+              <a:t>Adjunta un informe de evaluación público en Copilot Chat y pide la síntesis extractiva. Dile expresamente que transcriba oraciones textuales sin reescribirlas, y que las ponga entre comillas.</a:t>
             </a:r>
             <a:endParaRPr lang="en-US" sz="1450" dirty="0"/>
           </a:p>
@@ -11101,7 +11101,7 @@
                 <a:ea typeface="Calibri" pitchFamily="34" charset="-122"/>
                 <a:cs typeface="Calibri" pitchFamily="34" charset="-120"/>
               </a:rPr>
-              <a:t>Se hace en Copilot dentro de Excel. Plantilla en Plantillas_tabulares_curso_IA.xlsx.</a:t>
+              <a:t>Se hace en Copilot Chat con los tres documentos adjuntos. La tabla final la pegas en la plantilla de Plantillas_tabulares_curso_IA.xlsx.</a:t>
             </a:r>
             <a:endParaRPr lang="en-US" sz="1350" dirty="0"/>
           </a:p>

</xml_diff>

<commit_message>
Módulo II: la intuición de cómo una máquina compara textos
- Sesión 4: dos láminas nuevas antes de la Práctica C, con los conteos
  reales de los 118 registros. TF-IDF como «frecuente aquí, raro en el
  resto» y los dos modos en que contar palabras falla. Práctica A baja a
  12 minutos para pagarlas y la agenda se recorre.
- Sesión 5: el anclaje a una carpeta se explica por cercanía de
  significado, que es la misma idea del viernes aplicada al RAG.
- Anexo visual «De las palabras a los números» para la charla del receso,
  con el puente a Gower y al Módulo III.
- Handouts 4 y 5 al día; el handout 4 renumera sus secciones.

Co-Authored-By: Claude Opus 5 <noreply@anthropic.com>
</commit_message>
<xml_diff>
--- a/sesion-04/Sesion_04_PLN_Gestion_Documental.pptx
+++ b/sesion-04/Sesion_04_PLN_Gestion_Documental.pptx
@@ -14,6 +14,8 @@
     <p:sldId id="262" r:id="rId8"/>
     <p:sldId id="263" r:id="rId9"/>
     <p:sldId id="264" r:id="rId10"/>
+    <p:sldId id="271" r:id="rId22"/>
+    <p:sldId id="272" r:id="rId23"/>
     <p:sldId id="265" r:id="rId11"/>
     <p:sldId id="266" r:id="rId12"/>
     <p:sldId id="267" r:id="rId13"/>
@@ -1086,6 +1088,206 @@
 </p:notes>
 </file>
 
+<file path=ppt/notesSlides/notesSlide16.xml><?xml version="1.0" encoding="utf-8"?>
+<p:notes xmlns:a="http://schemas.openxmlformats.org/drawingml/2006/main" xmlns:r="http://schemas.openxmlformats.org/officeDocument/2006/relationships" xmlns:p="http://schemas.openxmlformats.org/presentationml/2006/main">
+  <p:cSld>
+    <p:spTree>
+      <p:nvGrpSpPr>
+        <p:cNvPr id="1" name=""/>
+        <p:cNvGrpSpPr/>
+        <p:nvPr/>
+      </p:nvGrpSpPr>
+      <p:grpSpPr>
+        <a:xfrm>
+          <a:off x="0" y="0"/>
+          <a:ext cx="0" cy="0"/>
+          <a:chOff x="0" y="0"/>
+          <a:chExt cx="0" cy="0"/>
+        </a:xfrm>
+      </p:grpSpPr>
+      <p:sp>
+        <p:nvSpPr>
+          <p:cNvPr id="2" name="Slide Image Placeholder 1"/>
+          <p:cNvSpPr>
+            <a:spLocks noGrp="1" noRot="1" noChangeAspect="1"/>
+          </p:cNvSpPr>
+          <p:nvPr>
+            <p:ph type="sldImg"/>
+          </p:nvPr>
+        </p:nvSpPr>
+        <p:spPr/>
+      </p:sp>
+      <p:sp>
+        <p:nvSpPr>
+          <p:cNvPr id="3" name="Notes Placeholder 2"/>
+          <p:cNvSpPr>
+            <a:spLocks noGrp="1"/>
+          </p:cNvSpPr>
+          <p:nvPr>
+            <p:ph type="body" idx="1"/>
+          </p:nvPr>
+        </p:nvSpPr>
+        <p:spPr/>
+        <p:txBody>
+          <a:bodyPr/>
+          <a:lstStyle/>
+          <a:p>
+            <a:r>
+              <a:rPr lang="en-US" dirty="0"/>
+              <a:t>Seis minutos. La frase que tienen que salir diciendo es «frecuente aquí, raro en el resto».</a:t>
+            </a:r>
+          </a:p>
+          <a:p>
+            <a:r>
+              <a:rPr lang="en-US" dirty="0"/>
+              <a:t>Los conteos son reales: se calcularon sobre los 118 registros que ellos van a clasificar en la Práctica C.</a:t>
+            </a:r>
+          </a:p>
+          <a:p>
+            <a:r>
+              <a:rPr lang="en-US" dirty="0"/>
+              <a:t>El remate es el que importa para la evaluación: la minoría no se pierde por descuido del modelo, se pierde por cómo está construida la medida. Enlaza con el sesgo de mayoría de la sesión 1.</a:t>
+            </a:r>
+          </a:p>
+          <a:p>
+            <a:r>
+              <a:rPr lang="en-US" dirty="0"/>
+              <a:t>Si alguien del área de ciencia de datos pregunta por la fórmula, remítelo al anexo y a la charla del receso: en clase no se escribe ninguna fórmula.</a:t>
+            </a:r>
+          </a:p>
+        </p:txBody>
+      </p:sp>
+      <p:sp>
+        <p:nvSpPr>
+          <p:cNvPr id="4" name="Slide Number Placeholder 3"/>
+          <p:cNvSpPr>
+            <a:spLocks noGrp="1"/>
+          </p:cNvSpPr>
+          <p:nvPr>
+            <p:ph type="sldNum" sz="quarter" idx="10"/>
+          </p:nvPr>
+        </p:nvSpPr>
+        <p:spPr/>
+        <p:txBody>
+          <a:bodyPr/>
+          <a:lstStyle/>
+          <a:p>
+            <a:fld id="{A7C21451-1387-4CA6-816F-3879F97B5CB2}" type="slidenum">
+              <a:rPr lang="en-US"/>
+              <a:t>10</a:t>
+            </a:fld>
+            <a:endParaRPr lang="en-US"/>
+          </a:p>
+        </p:txBody>
+      </p:sp>
+    </p:spTree>
+  </p:cSld>
+  <p:clrMapOvr>
+    <a:masterClrMapping/>
+  </p:clrMapOvr>
+</p:notes>
+</file>
+
+<file path=ppt/notesSlides/notesSlide17.xml><?xml version="1.0" encoding="utf-8"?>
+<p:notes xmlns:a="http://schemas.openxmlformats.org/drawingml/2006/main" xmlns:r="http://schemas.openxmlformats.org/officeDocument/2006/relationships" xmlns:p="http://schemas.openxmlformats.org/presentationml/2006/main">
+  <p:cSld>
+    <p:spTree>
+      <p:nvGrpSpPr>
+        <p:cNvPr id="1" name=""/>
+        <p:cNvGrpSpPr/>
+        <p:nvPr/>
+      </p:nvGrpSpPr>
+      <p:grpSpPr>
+        <a:xfrm>
+          <a:off x="0" y="0"/>
+          <a:ext cx="0" cy="0"/>
+          <a:chOff x="0" y="0"/>
+          <a:chExt cx="0" cy="0"/>
+        </a:xfrm>
+      </p:grpSpPr>
+      <p:sp>
+        <p:nvSpPr>
+          <p:cNvPr id="2" name="Slide Image Placeholder 1"/>
+          <p:cNvSpPr>
+            <a:spLocks noGrp="1" noRot="1" noChangeAspect="1"/>
+          </p:cNvSpPr>
+          <p:nvPr>
+            <p:ph type="sldImg"/>
+          </p:nvPr>
+        </p:nvSpPr>
+        <p:spPr/>
+      </p:sp>
+      <p:sp>
+        <p:nvSpPr>
+          <p:cNvPr id="3" name="Notes Placeholder 2"/>
+          <p:cNvSpPr>
+            <a:spLocks noGrp="1"/>
+          </p:cNvSpPr>
+          <p:nvPr>
+            <p:ph type="body" idx="1"/>
+          </p:nvPr>
+        </p:nvSpPr>
+        <p:spPr/>
+        <p:txBody>
+          <a:bodyPr/>
+          <a:lstStyle/>
+          <a:p>
+            <a:r>
+              <a:rPr lang="en-US" dirty="0"/>
+              <a:t>Seis minutos. Lee las cuatro citas en voz alta antes de explicar nada: el grupo suele detectar solo el par que comparte palabras.</a:t>
+            </a:r>
+          </a:p>
+          <a:p>
+            <a:r>
+              <a:rPr lang="en-US" dirty="0"/>
+              <a:t>La pregunta que abre la discusión: ¿cuál de los dos errores es más caro en una evaluación? Normalmente llegan a que juntar temas distintos infla una categoría y separar el mismo tema esconde un problema.</a:t>
+            </a:r>
+          </a:p>
+          <a:p>
+            <a:r>
+              <a:rPr lang="en-US" dirty="0"/>
+              <a:t>Aquí se anuncia la charla opcional del receso, de diez minutos, sobre el anexo visual: sesion-04/Anexo_De_las_palabras_a_los_numeros.pptx.</a:t>
+            </a:r>
+          </a:p>
+          <a:p>
+            <a:r>
+              <a:rPr lang="en-US" dirty="0"/>
+              <a:t>Gower solo se nombra, no se explica. Es el gancho del Módulo III para quienes trabajan con padrones y tablas.</a:t>
+            </a:r>
+          </a:p>
+        </p:txBody>
+      </p:sp>
+      <p:sp>
+        <p:nvSpPr>
+          <p:cNvPr id="4" name="Slide Number Placeholder 3"/>
+          <p:cNvSpPr>
+            <a:spLocks noGrp="1"/>
+          </p:cNvSpPr>
+          <p:nvPr>
+            <p:ph type="sldNum" sz="quarter" idx="10"/>
+          </p:nvPr>
+        </p:nvSpPr>
+        <p:spPr/>
+        <p:txBody>
+          <a:bodyPr/>
+          <a:lstStyle/>
+          <a:p>
+            <a:fld id="{A7C21451-1387-4CA6-816F-3879F97B5CB2}" type="slidenum">
+              <a:rPr lang="en-US"/>
+              <a:t>11</a:t>
+            </a:fld>
+            <a:endParaRPr lang="en-US"/>
+          </a:p>
+        </p:txBody>
+      </p:sp>
+    </p:spTree>
+  </p:cSld>
+  <p:clrMapOvr>
+    <a:masterClrMapping/>
+  </p:clrMapOvr>
+</p:notes>
+</file>
+
 <file path=ppt/notesSlides/notesSlide2.xml><?xml version="1.0" encoding="utf-8"?>
 <p:notes xmlns:a="http://schemas.openxmlformats.org/drawingml/2006/main" xmlns:r="http://schemas.openxmlformats.org/officeDocument/2006/relationships" xmlns:p="http://schemas.openxmlformats.org/presentationml/2006/main">
   <p:cSld>
@@ -6482,9 +6684,9 @@
 </p:sld>
 </file>
 
-<file path=ppt/slides/slide2.xml><?xml version="1.0" encoding="utf-8"?>
+<file path=ppt/slides/slide16.xml><?xml version="1.0" encoding="utf-8"?>
 <p:sld xmlns:a="http://schemas.openxmlformats.org/drawingml/2006/main" xmlns:r="http://schemas.openxmlformats.org/officeDocument/2006/relationships" xmlns:p="http://schemas.openxmlformats.org/presentationml/2006/main">
-  <p:cSld name="Slide 2">
+  <p:cSld name="TF-IDF">
     <p:spTree>
       <p:nvGrpSpPr>
         <p:cNvPr id="1" name=""/>
@@ -6501,14 +6703,14 @@
       </p:grpSpPr>
       <p:sp>
         <p:nvSpPr>
-          <p:cNvPr id="2" name="Text 0"/>
+          <p:cNvPr id="2" name="Text"/>
           <p:cNvSpPr txBox="1"/>
           <p:nvPr/>
         </p:nvSpPr>
         <p:spPr>
           <a:xfrm>
             <a:off x="566928" y="402336"/>
-            <a:ext cx="9229039" cy="749808"/>
+            <a:ext cx="11057839" cy="749808"/>
           </a:xfrm>
           <a:prstGeom prst="rect">
             <a:avLst/>
@@ -6532,7 +6734,7 @@
                 <a:ea typeface="Arial" pitchFamily="34" charset="-122"/>
                 <a:cs typeface="Arial" pitchFamily="34" charset="-120"/>
               </a:rPr>
-              <a:t>Cómo vamos a usar los 150 minutos</a:t>
+              <a:t>Cómo decide la máquina que dos textos se parecen</a:t>
             </a:r>
             <a:endParaRPr lang="en-US" sz="3200" dirty="0"/>
           </a:p>
@@ -6540,18 +6742,585 @@
       </p:sp>
       <p:sp>
         <p:nvSpPr>
-          <p:cNvPr id="3" name="Shape 1"/>
+          <p:cNvPr id="3" name="Text"/>
+          <p:cNvSpPr txBox="1"/>
+          <p:nvPr/>
+        </p:nvSpPr>
+        <p:spPr>
+          <a:xfrm>
+            <a:off x="566928" y="1280160"/>
+            <a:ext cx="11057839" cy="731520"/>
+          </a:xfrm>
+          <a:prstGeom prst="rect">
+            <a:avLst/>
+          </a:prstGeom>
+          <a:noFill/>
+          <a:ln/>
+        </p:spPr>
+        <p:txBody>
+          <a:bodyPr wrap="square" lIns="0" tIns="0" rIns="0" bIns="0" rtlCol="0" anchor="t"/>
+          <a:lstStyle/>
+          <a:p>
+            <a:pPr indent="0" marL="0">
+              <a:buNone/>
+            </a:pPr>
+            <a:r>
+              <a:rPr lang="en-US" sz="1500" dirty="0">
+                <a:solidFill>
+                  <a:srgbClr val="5A6B73"/>
+                </a:solidFill>
+                <a:latin typeface="Calibri" pitchFamily="34" charset="0"/>
+                <a:ea typeface="Calibri" pitchFamily="34" charset="-122"/>
+                <a:cs typeface="Calibri" pitchFamily="34" charset="-120"/>
+              </a:rPr>
+              <a:t>No lee: cuenta palabras y las pesa. Estos son los conteos reales de tus 118 registros de atención ciudadana.</a:t>
+            </a:r>
+            <a:endParaRPr lang="en-US" sz="1500" dirty="0"/>
+          </a:p>
+        </p:txBody>
+      </p:sp>
+      <p:sp>
+        <p:nvSpPr>
+          <p:cNvPr id="4" name="Shape"/>
           <p:cNvSpPr/>
           <p:nvPr/>
         </p:nvSpPr>
         <p:spPr>
           <a:xfrm>
-            <a:off x="9485071" y="457200"/>
-            <a:ext cx="2139696" cy="347472"/>
+            <a:off x="566928" y="1900000"/>
+            <a:ext cx="5460655" cy="3350000"/>
+          </a:xfrm>
+          <a:prstGeom prst="roundRect">
+            <a:avLst>
+              <a:gd name="adj" fmla="val 2933"/>
+            </a:avLst>
+          </a:prstGeom>
+          <a:solidFill>
+            <a:srgbClr val="D7E7E7"/>
+          </a:solidFill>
+          <a:ln w="12700">
+            <a:solidFill>
+              <a:srgbClr val="D7E7E7"/>
+            </a:solidFill>
+            <a:prstDash val="solid"/>
+          </a:ln>
+        </p:spPr>
+      </p:sp>
+      <p:sp>
+        <p:nvSpPr>
+          <p:cNvPr id="5" name="Text"/>
+          <p:cNvSpPr txBox="1"/>
+          <p:nvPr/>
+        </p:nvSpPr>
+        <p:spPr>
+          <a:xfrm>
+            <a:off x="841248" y="2100000"/>
+            <a:ext cx="4912015" cy="365760"/>
+          </a:xfrm>
+          <a:prstGeom prst="rect">
+            <a:avLst/>
+          </a:prstGeom>
+          <a:noFill/>
+          <a:ln/>
+        </p:spPr>
+        <p:txBody>
+          <a:bodyPr wrap="square" lIns="0" tIns="0" rIns="0" bIns="0" rtlCol="0" anchor="t"/>
+          <a:lstStyle/>
+          <a:p>
+            <a:pPr indent="0" marL="0">
+              <a:buNone/>
+            </a:pPr>
+            <a:r>
+              <a:rPr lang="en-US" sz="1700" b="1" dirty="0">
+                <a:solidFill>
+                  <a:srgbClr val="2E7D7D"/>
+                </a:solidFill>
+                <a:latin typeface="Arial" pitchFamily="34" charset="0"/>
+                <a:ea typeface="Arial" pitchFamily="34" charset="-122"/>
+                <a:cs typeface="Arial" pitchFamily="34" charset="-120"/>
+              </a:rPr>
+              <a:t>Las que no distinguen nada</a:t>
+            </a:r>
+            <a:endParaRPr lang="en-US" sz="1700" dirty="0"/>
+          </a:p>
+        </p:txBody>
+      </p:sp>
+      <p:sp>
+        <p:nvSpPr>
+          <p:cNvPr id="6" name="Text"/>
+          <p:cNvSpPr txBox="1"/>
+          <p:nvPr/>
+        </p:nvSpPr>
+        <p:spPr>
+          <a:xfrm>
+            <a:off x="841248" y="2530000"/>
+            <a:ext cx="4912015" cy="400000"/>
+          </a:xfrm>
+          <a:prstGeom prst="rect">
+            <a:avLst/>
+          </a:prstGeom>
+          <a:noFill/>
+          <a:ln/>
+        </p:spPr>
+        <p:txBody>
+          <a:bodyPr wrap="square" lIns="0" tIns="0" rIns="0" bIns="0" rtlCol="0" anchor="t"/>
+          <a:lstStyle/>
+          <a:p>
+            <a:pPr indent="0" marL="0">
+              <a:lnSpc>
+                <a:spcPct val="110000"/>
+              </a:lnSpc>
+              <a:buNone/>
+            </a:pPr>
+            <a:r>
+              <a:rPr lang="en-US" sz="1250" dirty="0">
+                <a:solidFill>
+                  <a:srgbClr val="16262E"/>
+                </a:solidFill>
+                <a:latin typeface="Calibri" pitchFamily="34" charset="0"/>
+                <a:ea typeface="Calibri" pitchFamily="34" charset="-122"/>
+                <a:cs typeface="Calibri" pitchFamily="34" charset="-120"/>
+              </a:rPr>
+              <a:t>Están en casi todos los registros, así que no separan un tema de otro.</a:t>
+            </a:r>
+            <a:endParaRPr lang="en-US" sz="1250" dirty="0"/>
+          </a:p>
+        </p:txBody>
+      </p:sp>
+      <p:sp>
+        <p:nvSpPr>
+          <p:cNvPr id="7" name="Shape"/>
+          <p:cNvSpPr/>
+          <p:nvPr/>
+        </p:nvSpPr>
+        <p:spPr>
+          <a:xfrm>
+            <a:off x="841248" y="3050000"/>
+            <a:ext cx="3000000" cy="420000"/>
           </a:xfrm>
           <a:prstGeom prst="roundRect">
             <a:avLst>
               <a:gd name="adj" fmla="val 50000"/>
+            </a:avLst>
+          </a:prstGeom>
+          <a:solidFill>
+            <a:srgbClr val="FFFFFF"/>
+          </a:solidFill>
+          <a:ln w="12700">
+            <a:solidFill>
+              <a:srgbClr val="FFFFFF"/>
+            </a:solidFill>
+            <a:prstDash val="solid"/>
+          </a:ln>
+        </p:spPr>
+      </p:sp>
+      <p:sp>
+        <p:nvSpPr>
+          <p:cNvPr id="8" name="Text"/>
+          <p:cNvSpPr txBox="1"/>
+          <p:nvPr/>
+        </p:nvSpPr>
+        <p:spPr>
+          <a:xfrm>
+            <a:off x="841248" y="3050000"/>
+            <a:ext cx="3000000" cy="420000"/>
+          </a:xfrm>
+          <a:prstGeom prst="rect">
+            <a:avLst/>
+          </a:prstGeom>
+          <a:noFill/>
+          <a:ln/>
+        </p:spPr>
+        <p:txBody>
+          <a:bodyPr wrap="square" lIns="0" tIns="0" rIns="0" bIns="0" rtlCol="0" anchor="ctr"/>
+          <a:lstStyle/>
+          <a:p>
+            <a:pPr algn="ctr" indent="0" marL="0">
+              <a:buNone/>
+            </a:pPr>
+            <a:r>
+              <a:rPr lang="en-US" sz="1300" b="1" dirty="0">
+                <a:solidFill>
+                  <a:srgbClr val="16262E"/>
+                </a:solidFill>
+                <a:latin typeface="Arial" pitchFamily="34" charset="0"/>
+                <a:ea typeface="Arial" pitchFamily="34" charset="-122"/>
+                <a:cs typeface="Arial" pitchFamily="34" charset="-120"/>
+              </a:rPr>
+              <a:t>modulo</a:t>
+            </a:r>
+            <a:endParaRPr lang="en-US" sz="1300" dirty="0"/>
+          </a:p>
+        </p:txBody>
+      </p:sp>
+      <p:sp>
+        <p:nvSpPr>
+          <p:cNvPr id="9" name="Text"/>
+          <p:cNvSpPr txBox="1"/>
+          <p:nvPr/>
+        </p:nvSpPr>
+        <p:spPr>
+          <a:xfrm>
+            <a:off x="3966928" y="3050000"/>
+            <a:ext cx="1700000" cy="420000"/>
+          </a:xfrm>
+          <a:prstGeom prst="rect">
+            <a:avLst/>
+          </a:prstGeom>
+          <a:noFill/>
+          <a:ln/>
+        </p:spPr>
+        <p:txBody>
+          <a:bodyPr wrap="square" lIns="0" tIns="0" rIns="0" bIns="0" rtlCol="0" anchor="ctr"/>
+          <a:lstStyle/>
+          <a:p>
+            <a:pPr indent="0" marL="0">
+              <a:buNone/>
+            </a:pPr>
+            <a:r>
+              <a:rPr lang="en-US" sz="1200" dirty="0">
+                <a:solidFill>
+                  <a:srgbClr val="5A6B73"/>
+                </a:solidFill>
+                <a:latin typeface="Calibri" pitchFamily="34" charset="0"/>
+                <a:ea typeface="Calibri" pitchFamily="34" charset="-122"/>
+                <a:cs typeface="Calibri" pitchFamily="34" charset="-120"/>
+              </a:rPr>
+              <a:t>14 de 118</a:t>
+            </a:r>
+            <a:endParaRPr lang="en-US" sz="1200" dirty="0"/>
+          </a:p>
+        </p:txBody>
+      </p:sp>
+      <p:sp>
+        <p:nvSpPr>
+          <p:cNvPr id="10" name="Shape"/>
+          <p:cNvSpPr/>
+          <p:nvPr/>
+        </p:nvSpPr>
+        <p:spPr>
+          <a:xfrm>
+            <a:off x="841248" y="3540000"/>
+            <a:ext cx="3000000" cy="420000"/>
+          </a:xfrm>
+          <a:prstGeom prst="roundRect">
+            <a:avLst>
+              <a:gd name="adj" fmla="val 50000"/>
+            </a:avLst>
+          </a:prstGeom>
+          <a:solidFill>
+            <a:srgbClr val="FFFFFF"/>
+          </a:solidFill>
+          <a:ln w="12700">
+            <a:solidFill>
+              <a:srgbClr val="FFFFFF"/>
+            </a:solidFill>
+            <a:prstDash val="solid"/>
+          </a:ln>
+        </p:spPr>
+      </p:sp>
+      <p:sp>
+        <p:nvSpPr>
+          <p:cNvPr id="11" name="Text"/>
+          <p:cNvSpPr txBox="1"/>
+          <p:nvPr/>
+        </p:nvSpPr>
+        <p:spPr>
+          <a:xfrm>
+            <a:off x="841248" y="3540000"/>
+            <a:ext cx="3000000" cy="420000"/>
+          </a:xfrm>
+          <a:prstGeom prst="rect">
+            <a:avLst/>
+          </a:prstGeom>
+          <a:noFill/>
+          <a:ln/>
+        </p:spPr>
+        <p:txBody>
+          <a:bodyPr wrap="square" lIns="0" tIns="0" rIns="0" bIns="0" rtlCol="0" anchor="ctr"/>
+          <a:lstStyle/>
+          <a:p>
+            <a:pPr algn="ctr" indent="0" marL="0">
+              <a:buNone/>
+            </a:pPr>
+            <a:r>
+              <a:rPr lang="en-US" sz="1300" b="1" dirty="0">
+                <a:solidFill>
+                  <a:srgbClr val="16262E"/>
+                </a:solidFill>
+                <a:latin typeface="Arial" pitchFamily="34" charset="0"/>
+                <a:ea typeface="Arial" pitchFamily="34" charset="-122"/>
+                <a:cs typeface="Arial" pitchFamily="34" charset="-120"/>
+              </a:rPr>
+              <a:t>tarjeta</a:t>
+            </a:r>
+            <a:endParaRPr lang="en-US" sz="1300" dirty="0"/>
+          </a:p>
+        </p:txBody>
+      </p:sp>
+      <p:sp>
+        <p:nvSpPr>
+          <p:cNvPr id="12" name="Text"/>
+          <p:cNvSpPr txBox="1"/>
+          <p:nvPr/>
+        </p:nvSpPr>
+        <p:spPr>
+          <a:xfrm>
+            <a:off x="3966928" y="3540000"/>
+            <a:ext cx="1700000" cy="420000"/>
+          </a:xfrm>
+          <a:prstGeom prst="rect">
+            <a:avLst/>
+          </a:prstGeom>
+          <a:noFill/>
+          <a:ln/>
+        </p:spPr>
+        <p:txBody>
+          <a:bodyPr wrap="square" lIns="0" tIns="0" rIns="0" bIns="0" rtlCol="0" anchor="ctr"/>
+          <a:lstStyle/>
+          <a:p>
+            <a:pPr indent="0" marL="0">
+              <a:buNone/>
+            </a:pPr>
+            <a:r>
+              <a:rPr lang="en-US" sz="1200" dirty="0">
+                <a:solidFill>
+                  <a:srgbClr val="5A6B73"/>
+                </a:solidFill>
+                <a:latin typeface="Calibri" pitchFamily="34" charset="0"/>
+                <a:ea typeface="Calibri" pitchFamily="34" charset="-122"/>
+                <a:cs typeface="Calibri" pitchFamily="34" charset="-120"/>
+              </a:rPr>
+              <a:t>12 de 118</a:t>
+            </a:r>
+            <a:endParaRPr lang="en-US" sz="1200" dirty="0"/>
+          </a:p>
+        </p:txBody>
+      </p:sp>
+      <p:sp>
+        <p:nvSpPr>
+          <p:cNvPr id="13" name="Shape"/>
+          <p:cNvSpPr/>
+          <p:nvPr/>
+        </p:nvSpPr>
+        <p:spPr>
+          <a:xfrm>
+            <a:off x="841248" y="4030000"/>
+            <a:ext cx="3000000" cy="420000"/>
+          </a:xfrm>
+          <a:prstGeom prst="roundRect">
+            <a:avLst>
+              <a:gd name="adj" fmla="val 50000"/>
+            </a:avLst>
+          </a:prstGeom>
+          <a:solidFill>
+            <a:srgbClr val="FFFFFF"/>
+          </a:solidFill>
+          <a:ln w="12700">
+            <a:solidFill>
+              <a:srgbClr val="FFFFFF"/>
+            </a:solidFill>
+            <a:prstDash val="solid"/>
+          </a:ln>
+        </p:spPr>
+      </p:sp>
+      <p:sp>
+        <p:nvSpPr>
+          <p:cNvPr id="14" name="Text"/>
+          <p:cNvSpPr txBox="1"/>
+          <p:nvPr/>
+        </p:nvSpPr>
+        <p:spPr>
+          <a:xfrm>
+            <a:off x="841248" y="4030000"/>
+            <a:ext cx="3000000" cy="420000"/>
+          </a:xfrm>
+          <a:prstGeom prst="rect">
+            <a:avLst/>
+          </a:prstGeom>
+          <a:noFill/>
+          <a:ln/>
+        </p:spPr>
+        <p:txBody>
+          <a:bodyPr wrap="square" lIns="0" tIns="0" rIns="0" bIns="0" rtlCol="0" anchor="ctr"/>
+          <a:lstStyle/>
+          <a:p>
+            <a:pPr algn="ctr" indent="0" marL="0">
+              <a:buNone/>
+            </a:pPr>
+            <a:r>
+              <a:rPr lang="en-US" sz="1300" b="1" dirty="0">
+                <a:solidFill>
+                  <a:srgbClr val="16262E"/>
+                </a:solidFill>
+                <a:latin typeface="Arial" pitchFamily="34" charset="0"/>
+                <a:ea typeface="Arial" pitchFamily="34" charset="-122"/>
+                <a:cs typeface="Arial" pitchFamily="34" charset="-120"/>
+              </a:rPr>
+              <a:t>tramite</a:t>
+            </a:r>
+            <a:endParaRPr lang="en-US" sz="1300" dirty="0"/>
+          </a:p>
+        </p:txBody>
+      </p:sp>
+      <p:sp>
+        <p:nvSpPr>
+          <p:cNvPr id="15" name="Text"/>
+          <p:cNvSpPr txBox="1"/>
+          <p:nvPr/>
+        </p:nvSpPr>
+        <p:spPr>
+          <a:xfrm>
+            <a:off x="3966928" y="4030000"/>
+            <a:ext cx="1700000" cy="420000"/>
+          </a:xfrm>
+          <a:prstGeom prst="rect">
+            <a:avLst/>
+          </a:prstGeom>
+          <a:noFill/>
+          <a:ln/>
+        </p:spPr>
+        <p:txBody>
+          <a:bodyPr wrap="square" lIns="0" tIns="0" rIns="0" bIns="0" rtlCol="0" anchor="ctr"/>
+          <a:lstStyle/>
+          <a:p>
+            <a:pPr indent="0" marL="0">
+              <a:buNone/>
+            </a:pPr>
+            <a:r>
+              <a:rPr lang="en-US" sz="1200" dirty="0">
+                <a:solidFill>
+                  <a:srgbClr val="5A6B73"/>
+                </a:solidFill>
+                <a:latin typeface="Calibri" pitchFamily="34" charset="0"/>
+                <a:ea typeface="Calibri" pitchFamily="34" charset="-122"/>
+                <a:cs typeface="Calibri" pitchFamily="34" charset="-120"/>
+              </a:rPr>
+              <a:t>10 de 118</a:t>
+            </a:r>
+            <a:endParaRPr lang="en-US" sz="1200" dirty="0"/>
+          </a:p>
+        </p:txBody>
+      </p:sp>
+      <p:sp>
+        <p:nvSpPr>
+          <p:cNvPr id="16" name="Shape"/>
+          <p:cNvSpPr/>
+          <p:nvPr/>
+        </p:nvSpPr>
+        <p:spPr>
+          <a:xfrm>
+            <a:off x="841248" y="4520000"/>
+            <a:ext cx="3000000" cy="420000"/>
+          </a:xfrm>
+          <a:prstGeom prst="roundRect">
+            <a:avLst>
+              <a:gd name="adj" fmla="val 50000"/>
+            </a:avLst>
+          </a:prstGeom>
+          <a:solidFill>
+            <a:srgbClr val="FFFFFF"/>
+          </a:solidFill>
+          <a:ln w="12700">
+            <a:solidFill>
+              <a:srgbClr val="FFFFFF"/>
+            </a:solidFill>
+            <a:prstDash val="solid"/>
+          </a:ln>
+        </p:spPr>
+      </p:sp>
+      <p:sp>
+        <p:nvSpPr>
+          <p:cNvPr id="17" name="Text"/>
+          <p:cNvSpPr txBox="1"/>
+          <p:nvPr/>
+        </p:nvSpPr>
+        <p:spPr>
+          <a:xfrm>
+            <a:off x="841248" y="4520000"/>
+            <a:ext cx="3000000" cy="420000"/>
+          </a:xfrm>
+          <a:prstGeom prst="rect">
+            <a:avLst/>
+          </a:prstGeom>
+          <a:noFill/>
+          <a:ln/>
+        </p:spPr>
+        <p:txBody>
+          <a:bodyPr wrap="square" lIns="0" tIns="0" rIns="0" bIns="0" rtlCol="0" anchor="ctr"/>
+          <a:lstStyle/>
+          <a:p>
+            <a:pPr algn="ctr" indent="0" marL="0">
+              <a:buNone/>
+            </a:pPr>
+            <a:r>
+              <a:rPr lang="en-US" sz="1300" b="1" dirty="0">
+                <a:solidFill>
+                  <a:srgbClr val="16262E"/>
+                </a:solidFill>
+                <a:latin typeface="Arial" pitchFamily="34" charset="0"/>
+                <a:ea typeface="Arial" pitchFamily="34" charset="-122"/>
+                <a:cs typeface="Arial" pitchFamily="34" charset="-120"/>
+              </a:rPr>
+              <a:t>cajero</a:t>
+            </a:r>
+            <a:endParaRPr lang="en-US" sz="1300" dirty="0"/>
+          </a:p>
+        </p:txBody>
+      </p:sp>
+      <p:sp>
+        <p:nvSpPr>
+          <p:cNvPr id="18" name="Text"/>
+          <p:cNvSpPr txBox="1"/>
+          <p:nvPr/>
+        </p:nvSpPr>
+        <p:spPr>
+          <a:xfrm>
+            <a:off x="3966928" y="4520000"/>
+            <a:ext cx="1700000" cy="420000"/>
+          </a:xfrm>
+          <a:prstGeom prst="rect">
+            <a:avLst/>
+          </a:prstGeom>
+          <a:noFill/>
+          <a:ln/>
+        </p:spPr>
+        <p:txBody>
+          <a:bodyPr wrap="square" lIns="0" tIns="0" rIns="0" bIns="0" rtlCol="0" anchor="ctr"/>
+          <a:lstStyle/>
+          <a:p>
+            <a:pPr indent="0" marL="0">
+              <a:buNone/>
+            </a:pPr>
+            <a:r>
+              <a:rPr lang="en-US" sz="1200" dirty="0">
+                <a:solidFill>
+                  <a:srgbClr val="5A6B73"/>
+                </a:solidFill>
+                <a:latin typeface="Calibri" pitchFamily="34" charset="0"/>
+                <a:ea typeface="Calibri" pitchFamily="34" charset="-122"/>
+                <a:cs typeface="Calibri" pitchFamily="34" charset="-120"/>
+              </a:rPr>
+              <a:t>7 de 118</a:t>
+            </a:r>
+            <a:endParaRPr lang="en-US" sz="1200" dirty="0"/>
+          </a:p>
+        </p:txBody>
+      </p:sp>
+      <p:sp>
+        <p:nvSpPr>
+          <p:cNvPr id="19" name="Shape"/>
+          <p:cNvSpPr/>
+          <p:nvPr/>
+        </p:nvSpPr>
+        <p:spPr>
+          <a:xfrm>
+            <a:off x="6164511" y="1900000"/>
+            <a:ext cx="5460655" cy="3350000"/>
+          </a:xfrm>
+          <a:prstGeom prst="roundRect">
+            <a:avLst>
+              <a:gd name="adj" fmla="val 2933"/>
             </a:avLst>
           </a:prstGeom>
           <a:solidFill>
@@ -6567,57 +7336,1472 @@
       </p:sp>
       <p:sp>
         <p:nvSpPr>
-          <p:cNvPr id="4" name="Text 2"/>
-          <p:cNvSpPr txBox="1"/>
-          <p:nvPr/>
-        </p:nvSpPr>
-        <p:spPr>
-          <a:xfrm>
-            <a:off x="9485071" y="457200"/>
-            <a:ext cx="2139696" cy="347472"/>
-          </a:xfrm>
-          <a:prstGeom prst="rect">
-            <a:avLst/>
-          </a:prstGeom>
-          <a:noFill/>
-          <a:ln/>
-        </p:spPr>
-        <p:txBody>
-          <a:bodyPr wrap="square" lIns="0" tIns="0" rIns="0" bIns="0" rtlCol="0" anchor="ctr"/>
-          <a:lstStyle/>
-          <a:p>
-            <a:pPr algn="ctr" indent="0" marL="0">
-              <a:buNone/>
-            </a:pPr>
-            <a:r>
-              <a:rPr lang="en-US" sz="1200" b="1" dirty="0">
+          <p:cNvPr id="20" name="Text"/>
+          <p:cNvSpPr txBox="1"/>
+          <p:nvPr/>
+        </p:nvSpPr>
+        <p:spPr>
+          <a:xfrm>
+            <a:off x="6438831" y="2100000"/>
+            <a:ext cx="4912015" cy="365760"/>
+          </a:xfrm>
+          <a:prstGeom prst="rect">
+            <a:avLst/>
+          </a:prstGeom>
+          <a:noFill/>
+          <a:ln/>
+        </p:spPr>
+        <p:txBody>
+          <a:bodyPr wrap="square" lIns="0" tIns="0" rIns="0" bIns="0" rtlCol="0" anchor="t"/>
+          <a:lstStyle/>
+          <a:p>
+            <a:pPr indent="0" marL="0">
+              <a:buNone/>
+            </a:pPr>
+            <a:r>
+              <a:rPr lang="en-US" sz="1700" b="1" dirty="0">
                 <a:solidFill>
                   <a:srgbClr val="5A6B73"/>
+                </a:solidFill>
+                <a:latin typeface="Arial" pitchFamily="34" charset="0"/>
+                <a:ea typeface="Arial" pitchFamily="34" charset="-122"/>
+                <a:cs typeface="Arial" pitchFamily="34" charset="-120"/>
+              </a:rPr>
+              <a:t>Las que sí marcan un tema</a:t>
+            </a:r>
+            <a:endParaRPr lang="en-US" sz="1700" dirty="0"/>
+          </a:p>
+        </p:txBody>
+      </p:sp>
+      <p:sp>
+        <p:nvSpPr>
+          <p:cNvPr id="21" name="Text"/>
+          <p:cNvSpPr txBox="1"/>
+          <p:nvPr/>
+        </p:nvSpPr>
+        <p:spPr>
+          <a:xfrm>
+            <a:off x="6438831" y="2530000"/>
+            <a:ext cx="4912015" cy="400000"/>
+          </a:xfrm>
+          <a:prstGeom prst="rect">
+            <a:avLst/>
+          </a:prstGeom>
+          <a:noFill/>
+          <a:ln/>
+        </p:spPr>
+        <p:txBody>
+          <a:bodyPr wrap="square" lIns="0" tIns="0" rIns="0" bIns="0" rtlCol="0" anchor="t"/>
+          <a:lstStyle/>
+          <a:p>
+            <a:pPr indent="0" marL="0">
+              <a:lnSpc>
+                <a:spcPct val="110000"/>
+              </a:lnSpc>
+              <a:buNone/>
+            </a:pPr>
+            <a:r>
+              <a:rPr lang="en-US" sz="1250" dirty="0">
+                <a:solidFill>
+                  <a:srgbClr val="16262E"/>
                 </a:solidFill>
                 <a:latin typeface="Calibri" pitchFamily="34" charset="0"/>
                 <a:ea typeface="Calibri" pitchFamily="34" charset="-122"/>
                 <a:cs typeface="Calibri" pitchFamily="34" charset="-120"/>
               </a:rPr>
-              <a:t>9:00 a 11:30</a:t>
-            </a:r>
-            <a:endParaRPr lang="en-US" sz="1200" dirty="0"/>
-          </a:p>
-        </p:txBody>
-      </p:sp>
-      <p:sp>
-        <p:nvSpPr>
-          <p:cNvPr id="5" name="Shape 3"/>
+              <a:t>Son raras en el resto del corpus, y por eso pesan cuando aparecen.</a:t>
+            </a:r>
+            <a:endParaRPr lang="en-US" sz="1250" dirty="0"/>
+          </a:p>
+        </p:txBody>
+      </p:sp>
+      <p:sp>
+        <p:nvSpPr>
+          <p:cNvPr id="22" name="Shape"/>
           <p:cNvSpPr/>
           <p:nvPr/>
         </p:nvSpPr>
         <p:spPr>
           <a:xfrm>
-            <a:off x="566928" y="1408176"/>
-            <a:ext cx="5364328" cy="1081278"/>
+            <a:off x="6438831" y="3050000"/>
+            <a:ext cx="3000000" cy="420000"/>
           </a:xfrm>
           <a:prstGeom prst="roundRect">
             <a:avLst>
-              <a:gd name="adj" fmla="val 5920"/>
+              <a:gd name="adj" fmla="val 50000"/>
+            </a:avLst>
+          </a:prstGeom>
+          <a:solidFill>
+            <a:srgbClr val="FFFFFF"/>
+          </a:solidFill>
+          <a:ln w="12700">
+            <a:solidFill>
+              <a:srgbClr val="FFFFFF"/>
+            </a:solidFill>
+            <a:prstDash val="solid"/>
+          </a:ln>
+        </p:spPr>
+      </p:sp>
+      <p:sp>
+        <p:nvSpPr>
+          <p:cNvPr id="23" name="Text"/>
+          <p:cNvSpPr txBox="1"/>
+          <p:nvPr/>
+        </p:nvSpPr>
+        <p:spPr>
+          <a:xfrm>
+            <a:off x="6438831" y="3050000"/>
+            <a:ext cx="3000000" cy="420000"/>
+          </a:xfrm>
+          <a:prstGeom prst="rect">
+            <a:avLst/>
+          </a:prstGeom>
+          <a:noFill/>
+          <a:ln/>
+        </p:spPr>
+        <p:txBody>
+          <a:bodyPr wrap="square" lIns="0" tIns="0" rIns="0" bIns="0" rtlCol="0" anchor="ctr"/>
+          <a:lstStyle/>
+          <a:p>
+            <a:pPr algn="ctr" indent="0" marL="0">
+              <a:buNone/>
+            </a:pPr>
+            <a:r>
+              <a:rPr lang="en-US" sz="1300" b="1" dirty="0">
+                <a:solidFill>
+                  <a:srgbClr val="16262E"/>
+                </a:solidFill>
+                <a:latin typeface="Arial" pitchFamily="34" charset="0"/>
+                <a:ea typeface="Arial" pitchFamily="34" charset="-122"/>
+                <a:cs typeface="Arial" pitchFamily="34" charset="-120"/>
+              </a:rPr>
+              <a:t>convocatoria</a:t>
+            </a:r>
+            <a:endParaRPr lang="en-US" sz="1300" dirty="0"/>
+          </a:p>
+        </p:txBody>
+      </p:sp>
+      <p:sp>
+        <p:nvSpPr>
+          <p:cNvPr id="24" name="Text"/>
+          <p:cNvSpPr txBox="1"/>
+          <p:nvPr/>
+        </p:nvSpPr>
+        <p:spPr>
+          <a:xfrm>
+            <a:off x="9564511" y="3050000"/>
+            <a:ext cx="1700000" cy="420000"/>
+          </a:xfrm>
+          <a:prstGeom prst="rect">
+            <a:avLst/>
+          </a:prstGeom>
+          <a:noFill/>
+          <a:ln/>
+        </p:spPr>
+        <p:txBody>
+          <a:bodyPr wrap="square" lIns="0" tIns="0" rIns="0" bIns="0" rtlCol="0" anchor="ctr"/>
+          <a:lstStyle/>
+          <a:p>
+            <a:pPr indent="0" marL="0">
+              <a:buNone/>
+            </a:pPr>
+            <a:r>
+              <a:rPr lang="en-US" sz="1200" dirty="0">
+                <a:solidFill>
+                  <a:srgbClr val="5A6B73"/>
+                </a:solidFill>
+                <a:latin typeface="Calibri" pitchFamily="34" charset="0"/>
+                <a:ea typeface="Calibri" pitchFamily="34" charset="-122"/>
+                <a:cs typeface="Calibri" pitchFamily="34" charset="-120"/>
+              </a:rPr>
+              <a:t>3 de 118</a:t>
+            </a:r>
+            <a:endParaRPr lang="en-US" sz="1200" dirty="0"/>
+          </a:p>
+        </p:txBody>
+      </p:sp>
+      <p:sp>
+        <p:nvSpPr>
+          <p:cNvPr id="25" name="Shape"/>
+          <p:cNvSpPr/>
+          <p:nvPr/>
+        </p:nvSpPr>
+        <p:spPr>
+          <a:xfrm>
+            <a:off x="6438831" y="3540000"/>
+            <a:ext cx="3000000" cy="420000"/>
+          </a:xfrm>
+          <a:prstGeom prst="roundRect">
+            <a:avLst>
+              <a:gd name="adj" fmla="val 50000"/>
+            </a:avLst>
+          </a:prstGeom>
+          <a:solidFill>
+            <a:srgbClr val="FFFFFF"/>
+          </a:solidFill>
+          <a:ln w="12700">
+            <a:solidFill>
+              <a:srgbClr val="FFFFFF"/>
+            </a:solidFill>
+            <a:prstDash val="solid"/>
+          </a:ln>
+        </p:spPr>
+      </p:sp>
+      <p:sp>
+        <p:nvSpPr>
+          <p:cNvPr id="26" name="Text"/>
+          <p:cNvSpPr txBox="1"/>
+          <p:nvPr/>
+        </p:nvSpPr>
+        <p:spPr>
+          <a:xfrm>
+            <a:off x="6438831" y="3540000"/>
+            <a:ext cx="3000000" cy="420000"/>
+          </a:xfrm>
+          <a:prstGeom prst="rect">
+            <a:avLst/>
+          </a:prstGeom>
+          <a:noFill/>
+          <a:ln/>
+        </p:spPr>
+        <p:txBody>
+          <a:bodyPr wrap="square" lIns="0" tIns="0" rIns="0" bIns="0" rtlCol="0" anchor="ctr"/>
+          <a:lstStyle/>
+          <a:p>
+            <a:pPr algn="ctr" indent="0" marL="0">
+              <a:buNone/>
+            </a:pPr>
+            <a:r>
+              <a:rPr lang="en-US" sz="1300" b="1" dirty="0">
+                <a:solidFill>
+                  <a:srgbClr val="16262E"/>
+                </a:solidFill>
+                <a:latin typeface="Arial" pitchFamily="34" charset="0"/>
+                <a:ea typeface="Arial" pitchFamily="34" charset="-122"/>
+                <a:cs typeface="Arial" pitchFamily="34" charset="-120"/>
+              </a:rPr>
+              <a:t>comprobante</a:t>
+            </a:r>
+            <a:endParaRPr lang="en-US" sz="1300" dirty="0"/>
+          </a:p>
+        </p:txBody>
+      </p:sp>
+      <p:sp>
+        <p:nvSpPr>
+          <p:cNvPr id="27" name="Text"/>
+          <p:cNvSpPr txBox="1"/>
+          <p:nvPr/>
+        </p:nvSpPr>
+        <p:spPr>
+          <a:xfrm>
+            <a:off x="9564511" y="3540000"/>
+            <a:ext cx="1700000" cy="420000"/>
+          </a:xfrm>
+          <a:prstGeom prst="rect">
+            <a:avLst/>
+          </a:prstGeom>
+          <a:noFill/>
+          <a:ln/>
+        </p:spPr>
+        <p:txBody>
+          <a:bodyPr wrap="square" lIns="0" tIns="0" rIns="0" bIns="0" rtlCol="0" anchor="ctr"/>
+          <a:lstStyle/>
+          <a:p>
+            <a:pPr indent="0" marL="0">
+              <a:buNone/>
+            </a:pPr>
+            <a:r>
+              <a:rPr lang="en-US" sz="1200" dirty="0">
+                <a:solidFill>
+                  <a:srgbClr val="5A6B73"/>
+                </a:solidFill>
+                <a:latin typeface="Calibri" pitchFamily="34" charset="0"/>
+                <a:ea typeface="Calibri" pitchFamily="34" charset="-122"/>
+                <a:cs typeface="Calibri" pitchFamily="34" charset="-120"/>
+              </a:rPr>
+              <a:t>3 de 118</a:t>
+            </a:r>
+            <a:endParaRPr lang="en-US" sz="1200" dirty="0"/>
+          </a:p>
+        </p:txBody>
+      </p:sp>
+      <p:sp>
+        <p:nvSpPr>
+          <p:cNvPr id="28" name="Shape"/>
+          <p:cNvSpPr/>
+          <p:nvPr/>
+        </p:nvSpPr>
+        <p:spPr>
+          <a:xfrm>
+            <a:off x="6438831" y="4030000"/>
+            <a:ext cx="3000000" cy="420000"/>
+          </a:xfrm>
+          <a:prstGeom prst="roundRect">
+            <a:avLst>
+              <a:gd name="adj" fmla="val 50000"/>
+            </a:avLst>
+          </a:prstGeom>
+          <a:solidFill>
+            <a:srgbClr val="FFFFFF"/>
+          </a:solidFill>
+          <a:ln w="12700">
+            <a:solidFill>
+              <a:srgbClr val="FFFFFF"/>
+            </a:solidFill>
+            <a:prstDash val="solid"/>
+          </a:ln>
+        </p:spPr>
+      </p:sp>
+      <p:sp>
+        <p:nvSpPr>
+          <p:cNvPr id="29" name="Text"/>
+          <p:cNvSpPr txBox="1"/>
+          <p:nvPr/>
+        </p:nvSpPr>
+        <p:spPr>
+          <a:xfrm>
+            <a:off x="6438831" y="4030000"/>
+            <a:ext cx="3000000" cy="420000"/>
+          </a:xfrm>
+          <a:prstGeom prst="rect">
+            <a:avLst/>
+          </a:prstGeom>
+          <a:noFill/>
+          <a:ln/>
+        </p:spPr>
+        <p:txBody>
+          <a:bodyPr wrap="square" lIns="0" tIns="0" rIns="0" bIns="0" rtlCol="0" anchor="ctr"/>
+          <a:lstStyle/>
+          <a:p>
+            <a:pPr algn="ctr" indent="0" marL="0">
+              <a:buNone/>
+            </a:pPr>
+            <a:r>
+              <a:rPr lang="en-US" sz="1300" b="1" dirty="0">
+                <a:solidFill>
+                  <a:srgbClr val="16262E"/>
+                </a:solidFill>
+                <a:latin typeface="Arial" pitchFamily="34" charset="0"/>
+                <a:ea typeface="Arial" pitchFamily="34" charset="-122"/>
+                <a:cs typeface="Arial" pitchFamily="34" charset="-120"/>
+              </a:rPr>
+              <a:t>rechazaron</a:t>
+            </a:r>
+            <a:endParaRPr lang="en-US" sz="1300" dirty="0"/>
+          </a:p>
+        </p:txBody>
+      </p:sp>
+      <p:sp>
+        <p:nvSpPr>
+          <p:cNvPr id="30" name="Text"/>
+          <p:cNvSpPr txBox="1"/>
+          <p:nvPr/>
+        </p:nvSpPr>
+        <p:spPr>
+          <a:xfrm>
+            <a:off x="9564511" y="4030000"/>
+            <a:ext cx="1700000" cy="420000"/>
+          </a:xfrm>
+          <a:prstGeom prst="rect">
+            <a:avLst/>
+          </a:prstGeom>
+          <a:noFill/>
+          <a:ln/>
+        </p:spPr>
+        <p:txBody>
+          <a:bodyPr wrap="square" lIns="0" tIns="0" rIns="0" bIns="0" rtlCol="0" anchor="ctr"/>
+          <a:lstStyle/>
+          <a:p>
+            <a:pPr indent="0" marL="0">
+              <a:buNone/>
+            </a:pPr>
+            <a:r>
+              <a:rPr lang="en-US" sz="1200" dirty="0">
+                <a:solidFill>
+                  <a:srgbClr val="5A6B73"/>
+                </a:solidFill>
+                <a:latin typeface="Calibri" pitchFamily="34" charset="0"/>
+                <a:ea typeface="Calibri" pitchFamily="34" charset="-122"/>
+                <a:cs typeface="Calibri" pitchFamily="34" charset="-120"/>
+              </a:rPr>
+              <a:t>3 de 118</a:t>
+            </a:r>
+            <a:endParaRPr lang="en-US" sz="1200" dirty="0"/>
+          </a:p>
+        </p:txBody>
+      </p:sp>
+      <p:sp>
+        <p:nvSpPr>
+          <p:cNvPr id="31" name="Shape"/>
+          <p:cNvSpPr/>
+          <p:nvPr/>
+        </p:nvSpPr>
+        <p:spPr>
+          <a:xfrm>
+            <a:off x="6438831" y="4520000"/>
+            <a:ext cx="3000000" cy="420000"/>
+          </a:xfrm>
+          <a:prstGeom prst="roundRect">
+            <a:avLst>
+              <a:gd name="adj" fmla="val 50000"/>
+            </a:avLst>
+          </a:prstGeom>
+          <a:solidFill>
+            <a:srgbClr val="FFFFFF"/>
+          </a:solidFill>
+          <a:ln w="12700">
+            <a:solidFill>
+              <a:srgbClr val="FFFFFF"/>
+            </a:solidFill>
+            <a:prstDash val="solid"/>
+          </a:ln>
+        </p:spPr>
+      </p:sp>
+      <p:sp>
+        <p:nvSpPr>
+          <p:cNvPr id="32" name="Text"/>
+          <p:cNvSpPr txBox="1"/>
+          <p:nvPr/>
+        </p:nvSpPr>
+        <p:spPr>
+          <a:xfrm>
+            <a:off x="6438831" y="4520000"/>
+            <a:ext cx="3000000" cy="420000"/>
+          </a:xfrm>
+          <a:prstGeom prst="rect">
+            <a:avLst/>
+          </a:prstGeom>
+          <a:noFill/>
+          <a:ln/>
+        </p:spPr>
+        <p:txBody>
+          <a:bodyPr wrap="square" lIns="0" tIns="0" rIns="0" bIns="0" rtlCol="0" anchor="ctr"/>
+          <a:lstStyle/>
+          <a:p>
+            <a:pPr algn="ctr" indent="0" marL="0">
+              <a:buNone/>
+            </a:pPr>
+            <a:r>
+              <a:rPr lang="en-US" sz="1300" b="1" dirty="0">
+                <a:solidFill>
+                  <a:srgbClr val="16262E"/>
+                </a:solidFill>
+                <a:latin typeface="Arial" pitchFamily="34" charset="0"/>
+                <a:ea typeface="Arial" pitchFamily="34" charset="-122"/>
+                <a:cs typeface="Arial" pitchFamily="34" charset="-120"/>
+              </a:rPr>
+              <a:t>descalifica</a:t>
+            </a:r>
+            <a:endParaRPr lang="en-US" sz="1300" dirty="0"/>
+          </a:p>
+        </p:txBody>
+      </p:sp>
+      <p:sp>
+        <p:nvSpPr>
+          <p:cNvPr id="33" name="Text"/>
+          <p:cNvSpPr txBox="1"/>
+          <p:nvPr/>
+        </p:nvSpPr>
+        <p:spPr>
+          <a:xfrm>
+            <a:off x="9564511" y="4520000"/>
+            <a:ext cx="1700000" cy="420000"/>
+          </a:xfrm>
+          <a:prstGeom prst="rect">
+            <a:avLst/>
+          </a:prstGeom>
+          <a:noFill/>
+          <a:ln/>
+        </p:spPr>
+        <p:txBody>
+          <a:bodyPr wrap="square" lIns="0" tIns="0" rIns="0" bIns="0" rtlCol="0" anchor="ctr"/>
+          <a:lstStyle/>
+          <a:p>
+            <a:pPr indent="0" marL="0">
+              <a:buNone/>
+            </a:pPr>
+            <a:r>
+              <a:rPr lang="en-US" sz="1200" dirty="0">
+                <a:solidFill>
+                  <a:srgbClr val="5A6B73"/>
+                </a:solidFill>
+                <a:latin typeface="Calibri" pitchFamily="34" charset="0"/>
+                <a:ea typeface="Calibri" pitchFamily="34" charset="-122"/>
+                <a:cs typeface="Calibri" pitchFamily="34" charset="-120"/>
+              </a:rPr>
+              <a:t>2 de 118</a:t>
+            </a:r>
+            <a:endParaRPr lang="en-US" sz="1200" dirty="0"/>
+          </a:p>
+        </p:txBody>
+      </p:sp>
+      <p:sp>
+        <p:nvSpPr>
+          <p:cNvPr id="34" name="Shape"/>
+          <p:cNvSpPr/>
+          <p:nvPr/>
+        </p:nvSpPr>
+        <p:spPr>
+          <a:xfrm>
+            <a:off x="566928" y="5824728"/>
+            <a:ext cx="11057839" cy="594360"/>
+          </a:xfrm>
+          <a:prstGeom prst="roundRect">
+            <a:avLst>
+              <a:gd name="adj" fmla="val 8235"/>
+            </a:avLst>
+          </a:prstGeom>
+          <a:solidFill>
+            <a:srgbClr val="F7E4D8"/>
+          </a:solidFill>
+          <a:ln w="12700">
+            <a:solidFill>
+              <a:srgbClr val="F7E4D8"/>
+            </a:solidFill>
+            <a:prstDash val="solid"/>
+          </a:ln>
+        </p:spPr>
+      </p:sp>
+      <p:sp>
+        <p:nvSpPr>
+          <p:cNvPr id="35" name="Text"/>
+          <p:cNvSpPr txBox="1"/>
+          <p:nvPr/>
+        </p:nvSpPr>
+        <p:spPr>
+          <a:xfrm>
+            <a:off x="804672" y="5824728"/>
+            <a:ext cx="10582351" cy="594360"/>
+          </a:xfrm>
+          <a:prstGeom prst="rect">
+            <a:avLst/>
+          </a:prstGeom>
+          <a:noFill/>
+          <a:ln/>
+        </p:spPr>
+        <p:txBody>
+          <a:bodyPr wrap="square" lIns="0" tIns="0" rIns="0" bIns="0" rtlCol="0" anchor="ctr"/>
+          <a:lstStyle/>
+          <a:p>
+            <a:pPr indent="0" marL="0">
+              <a:lnSpc>
+                <a:spcPct val="110000"/>
+              </a:lnSpc>
+              <a:buNone/>
+            </a:pPr>
+            <a:r>
+              <a:rPr lang="en-US" sz="1300" dirty="0">
+                <a:solidFill>
+                  <a:srgbClr val="16262E"/>
+                </a:solidFill>
+                <a:latin typeface="Calibri" pitchFamily="34" charset="0"/>
+                <a:ea typeface="Calibri" pitchFamily="34" charset="-122"/>
+                <a:cs typeface="Calibri" pitchFamily="34" charset="-120"/>
+              </a:rPr>
+              <a:t>TF-IDF cabe en una frase: una palabra pesa cuando es frecuente aquí y rara en el resto. De ahí sale algo que te importa: una queja poco frecuente nunca junta peso suficiente para volverse categoría, y termina en la bolsa de «otros».</a:t>
+            </a:r>
+            <a:endParaRPr lang="en-US" sz="1300" dirty="0"/>
+          </a:p>
+        </p:txBody>
+      </p:sp>
+    </p:spTree>
+  </p:cSld>
+  <p:clrMapOvr>
+    <a:masterClrMapping/>
+  </p:clrMapOvr>
+</p:sld>
+</file>
+
+<file path=ppt/slides/slide17.xml><?xml version="1.0" encoding="utf-8"?>
+<p:sld xmlns:a="http://schemas.openxmlformats.org/drawingml/2006/main" xmlns:r="http://schemas.openxmlformats.org/officeDocument/2006/relationships" xmlns:p="http://schemas.openxmlformats.org/presentationml/2006/main">
+  <p:cSld name="Vectores">
+    <p:spTree>
+      <p:nvGrpSpPr>
+        <p:cNvPr id="1" name=""/>
+        <p:cNvGrpSpPr/>
+        <p:nvPr/>
+      </p:nvGrpSpPr>
+      <p:grpSpPr>
+        <a:xfrm>
+          <a:off x="0" y="0"/>
+          <a:ext cx="0" cy="0"/>
+          <a:chOff x="0" y="0"/>
+          <a:chExt cx="0" cy="0"/>
+        </a:xfrm>
+      </p:grpSpPr>
+      <p:sp>
+        <p:nvSpPr>
+          <p:cNvPr id="2" name="Text"/>
+          <p:cNvSpPr txBox="1"/>
+          <p:nvPr/>
+        </p:nvSpPr>
+        <p:spPr>
+          <a:xfrm>
+            <a:off x="566928" y="402336"/>
+            <a:ext cx="11057839" cy="749808"/>
+          </a:xfrm>
+          <a:prstGeom prst="rect">
+            <a:avLst/>
+          </a:prstGeom>
+          <a:noFill/>
+          <a:ln/>
+        </p:spPr>
+        <p:txBody>
+          <a:bodyPr wrap="square" lIns="0" tIns="0" rIns="0" bIns="0" rtlCol="0" anchor="t"/>
+          <a:lstStyle/>
+          <a:p>
+            <a:pPr algn="l" indent="0" marL="0">
+              <a:buNone/>
+            </a:pPr>
+            <a:r>
+              <a:rPr lang="en-US" sz="3200" b="1" dirty="0">
+                <a:solidFill>
+                  <a:srgbClr val="16262E"/>
+                </a:solidFill>
+                <a:latin typeface="Arial" pitchFamily="34" charset="0"/>
+                <a:ea typeface="Arial" pitchFamily="34" charset="-122"/>
+                <a:cs typeface="Arial" pitchFamily="34" charset="-120"/>
+              </a:rPr>
+              <a:t>Contar palabras falla en dos direcciones</a:t>
+            </a:r>
+            <a:endParaRPr lang="en-US" sz="3200" dirty="0"/>
+          </a:p>
+        </p:txBody>
+      </p:sp>
+      <p:sp>
+        <p:nvSpPr>
+          <p:cNvPr id="3" name="Text"/>
+          <p:cNvSpPr txBox="1"/>
+          <p:nvPr/>
+        </p:nvSpPr>
+        <p:spPr>
+          <a:xfrm>
+            <a:off x="566928" y="1280160"/>
+            <a:ext cx="11057839" cy="731520"/>
+          </a:xfrm>
+          <a:prstGeom prst="rect">
+            <a:avLst/>
+          </a:prstGeom>
+          <a:noFill/>
+          <a:ln/>
+        </p:spPr>
+        <p:txBody>
+          <a:bodyPr wrap="square" lIns="0" tIns="0" rIns="0" bIns="0" rtlCol="0" anchor="t"/>
+          <a:lstStyle/>
+          <a:p>
+            <a:pPr indent="0" marL="0">
+              <a:buNone/>
+            </a:pPr>
+            <a:r>
+              <a:rPr lang="en-US" sz="1500" dirty="0">
+                <a:solidFill>
+                  <a:srgbClr val="5A6B73"/>
+                </a:solidFill>
+                <a:latin typeface="Calibri" pitchFamily="34" charset="0"/>
+                <a:ea typeface="Calibri" pitchFamily="34" charset="-122"/>
+                <a:cs typeface="Calibri" pitchFamily="34" charset="-120"/>
+              </a:rPr>
+              <a:t>Cuatro registros reales del corpus de hoy. A la izquierda comparten palabras y no comparten tema; a la derecha es exactamente al revés.</a:t>
+            </a:r>
+            <a:endParaRPr lang="en-US" sz="1500" dirty="0"/>
+          </a:p>
+        </p:txBody>
+      </p:sp>
+      <p:sp>
+        <p:nvSpPr>
+          <p:cNvPr id="4" name="Shape"/>
+          <p:cNvSpPr/>
+          <p:nvPr/>
+        </p:nvSpPr>
+        <p:spPr>
+          <a:xfrm>
+            <a:off x="566928" y="1900000"/>
+            <a:ext cx="5460655" cy="3700000"/>
+          </a:xfrm>
+          <a:prstGeom prst="roundRect">
+            <a:avLst>
+              <a:gd name="adj" fmla="val 2933"/>
+            </a:avLst>
+          </a:prstGeom>
+          <a:solidFill>
+            <a:srgbClr val="F7E4D8"/>
+          </a:solidFill>
+          <a:ln w="12700">
+            <a:solidFill>
+              <a:srgbClr val="F7E4D8"/>
+            </a:solidFill>
+            <a:prstDash val="solid"/>
+          </a:ln>
+        </p:spPr>
+      </p:sp>
+      <p:sp>
+        <p:nvSpPr>
+          <p:cNvPr id="5" name="Text"/>
+          <p:cNvSpPr txBox="1"/>
+          <p:nvPr/>
+        </p:nvSpPr>
+        <p:spPr>
+          <a:xfrm>
+            <a:off x="796928" y="2080000"/>
+            <a:ext cx="5000655" cy="330000"/>
+          </a:xfrm>
+          <a:prstGeom prst="rect">
+            <a:avLst/>
+          </a:prstGeom>
+          <a:noFill/>
+          <a:ln/>
+        </p:spPr>
+        <p:txBody>
+          <a:bodyPr wrap="square" lIns="0" tIns="0" rIns="0" bIns="0" rtlCol="0" anchor="t"/>
+          <a:lstStyle/>
+          <a:p>
+            <a:pPr indent="0" marL="0">
+              <a:buNone/>
+            </a:pPr>
+            <a:r>
+              <a:rPr lang="en-US" sz="1600" b="1" dirty="0">
+                <a:solidFill>
+                  <a:srgbClr val="C85A28"/>
+                </a:solidFill>
+                <a:latin typeface="Arial" pitchFamily="34" charset="0"/>
+                <a:ea typeface="Arial" pitchFamily="34" charset="-122"/>
+                <a:cs typeface="Arial" pitchFamily="34" charset="-120"/>
+              </a:rPr>
+              <a:t>Mismas palabras, distinto tema</a:t>
+            </a:r>
+            <a:endParaRPr lang="en-US" sz="1600" dirty="0"/>
+          </a:p>
+        </p:txBody>
+      </p:sp>
+      <p:sp>
+        <p:nvSpPr>
+          <p:cNvPr id="6" name="Shape"/>
+          <p:cNvSpPr/>
+          <p:nvPr/>
+        </p:nvSpPr>
+        <p:spPr>
+          <a:xfrm>
+            <a:off x="796928" y="2440000"/>
+            <a:ext cx="5000000" cy="1160000"/>
+          </a:xfrm>
+          <a:prstGeom prst="roundRect">
+            <a:avLst>
+              <a:gd name="adj" fmla="val 8000"/>
+            </a:avLst>
+          </a:prstGeom>
+          <a:solidFill>
+            <a:srgbClr val="FFFFFF"/>
+          </a:solidFill>
+          <a:ln w="12700">
+            <a:solidFill>
+              <a:srgbClr val="FFFFFF"/>
+            </a:solidFill>
+            <a:prstDash val="solid"/>
+          </a:ln>
+        </p:spPr>
+      </p:sp>
+      <p:sp>
+        <p:nvSpPr>
+          <p:cNvPr id="7" name="Text"/>
+          <p:cNvSpPr txBox="1"/>
+          <p:nvPr/>
+        </p:nvSpPr>
+        <p:spPr>
+          <a:xfrm>
+            <a:off x="1036928" y="2560000"/>
+            <a:ext cx="4520000" cy="760000"/>
+          </a:xfrm>
+          <a:prstGeom prst="rect">
+            <a:avLst/>
+          </a:prstGeom>
+          <a:noFill/>
+          <a:ln/>
+        </p:spPr>
+        <p:txBody>
+          <a:bodyPr wrap="square" lIns="0" tIns="0" rIns="0" bIns="0" rtlCol="0" anchor="t"/>
+          <a:lstStyle/>
+          <a:p>
+            <a:pPr indent="0" marL="0">
+              <a:lnSpc>
+                <a:spcPct val="105000"/>
+              </a:lnSpc>
+              <a:buNone/>
+            </a:pPr>
+            <a:r>
+              <a:rPr lang="en-US" sz="1250" dirty="0">
+                <a:solidFill>
+                  <a:srgbClr val="16262E"/>
+                </a:solidFill>
+                <a:latin typeface="Calibri" pitchFamily="34" charset="0"/>
+                <a:ea typeface="Calibri" pitchFamily="34" charset="-122"/>
+                <a:cs typeface="Calibri" pitchFamily="34" charset="-120"/>
+              </a:rPr>
+              <a:t>«Manifiesta que su esposo cobró con su tarjeta sin su permiso y quiere saber cómo cambiar el NIP.»</a:t>
+            </a:r>
+            <a:endParaRPr lang="en-US" sz="1250" dirty="0"/>
+          </a:p>
+        </p:txBody>
+      </p:sp>
+      <p:sp>
+        <p:nvSpPr>
+          <p:cNvPr id="8" name="Text"/>
+          <p:cNvSpPr txBox="1"/>
+          <p:nvPr/>
+        </p:nvSpPr>
+        <p:spPr>
+          <a:xfrm>
+            <a:off x="1036928" y="3320000"/>
+            <a:ext cx="4520000" cy="220000"/>
+          </a:xfrm>
+          <a:prstGeom prst="rect">
+            <a:avLst/>
+          </a:prstGeom>
+          <a:noFill/>
+          <a:ln/>
+        </p:spPr>
+        <p:txBody>
+          <a:bodyPr wrap="square" lIns="0" tIns="0" rIns="0" bIns="0" rtlCol="0" anchor="t"/>
+          <a:lstStyle/>
+          <a:p>
+            <a:pPr indent="0" marL="0">
+              <a:buNone/>
+            </a:pPr>
+            <a:r>
+              <a:rPr lang="en-US" sz="1050" dirty="0">
+                <a:solidFill>
+                  <a:srgbClr val="5A6B73"/>
+                </a:solidFill>
+                <a:latin typeface="Calibri" pitchFamily="34" charset="0"/>
+                <a:ea typeface="Calibri" pitchFamily="34" charset="-122"/>
+                <a:cs typeface="Calibri" pitchFamily="34" charset="-120"/>
+              </a:rPr>
+              <a:t>RAC-2025-00073</a:t>
+            </a:r>
+            <a:endParaRPr lang="en-US" sz="1050" dirty="0"/>
+          </a:p>
+        </p:txBody>
+      </p:sp>
+      <p:sp>
+        <p:nvSpPr>
+          <p:cNvPr id="9" name="Shape"/>
+          <p:cNvSpPr/>
+          <p:nvPr/>
+        </p:nvSpPr>
+        <p:spPr>
+          <a:xfrm>
+            <a:off x="796928" y="3660000"/>
+            <a:ext cx="5000000" cy="1160000"/>
+          </a:xfrm>
+          <a:prstGeom prst="roundRect">
+            <a:avLst>
+              <a:gd name="adj" fmla="val 8000"/>
+            </a:avLst>
+          </a:prstGeom>
+          <a:solidFill>
+            <a:srgbClr val="FFFFFF"/>
+          </a:solidFill>
+          <a:ln w="12700">
+            <a:solidFill>
+              <a:srgbClr val="FFFFFF"/>
+            </a:solidFill>
+            <a:prstDash val="solid"/>
+          </a:ln>
+        </p:spPr>
+      </p:sp>
+      <p:sp>
+        <p:nvSpPr>
+          <p:cNvPr id="10" name="Text"/>
+          <p:cNvSpPr txBox="1"/>
+          <p:nvPr/>
+        </p:nvSpPr>
+        <p:spPr>
+          <a:xfrm>
+            <a:off x="1036928" y="3780000"/>
+            <a:ext cx="4520000" cy="760000"/>
+          </a:xfrm>
+          <a:prstGeom prst="rect">
+            <a:avLst/>
+          </a:prstGeom>
+          <a:noFill/>
+          <a:ln/>
+        </p:spPr>
+        <p:txBody>
+          <a:bodyPr wrap="square" lIns="0" tIns="0" rIns="0" bIns="0" rtlCol="0" anchor="t"/>
+          <a:lstStyle/>
+          <a:p>
+            <a:pPr indent="0" marL="0">
+              <a:lnSpc>
+                <a:spcPct val="105000"/>
+              </a:lnSpc>
+              <a:buNone/>
+            </a:pPr>
+            <a:r>
+              <a:rPr lang="en-US" sz="1250" dirty="0">
+                <a:solidFill>
+                  <a:srgbClr val="16262E"/>
+                </a:solidFill>
+                <a:latin typeface="Calibri" pitchFamily="34" charset="0"/>
+                <a:ea typeface="Calibri" pitchFamily="34" charset="-122"/>
+                <a:cs typeface="Calibri" pitchFamily="34" charset="-120"/>
+              </a:rPr>
+              <a:t>«Su tarjeta caducó el mes pasado y quiere saber si el apoyo se pierde mientras le dan la nueva.»</a:t>
+            </a:r>
+            <a:endParaRPr lang="en-US" sz="1250" dirty="0"/>
+          </a:p>
+        </p:txBody>
+      </p:sp>
+      <p:sp>
+        <p:nvSpPr>
+          <p:cNvPr id="11" name="Text"/>
+          <p:cNvSpPr txBox="1"/>
+          <p:nvPr/>
+        </p:nvSpPr>
+        <p:spPr>
+          <a:xfrm>
+            <a:off x="1036928" y="4540000"/>
+            <a:ext cx="4520000" cy="220000"/>
+          </a:xfrm>
+          <a:prstGeom prst="rect">
+            <a:avLst/>
+          </a:prstGeom>
+          <a:noFill/>
+          <a:ln/>
+        </p:spPr>
+        <p:txBody>
+          <a:bodyPr wrap="square" lIns="0" tIns="0" rIns="0" bIns="0" rtlCol="0" anchor="t"/>
+          <a:lstStyle/>
+          <a:p>
+            <a:pPr indent="0" marL="0">
+              <a:buNone/>
+            </a:pPr>
+            <a:r>
+              <a:rPr lang="en-US" sz="1050" dirty="0">
+                <a:solidFill>
+                  <a:srgbClr val="5A6B73"/>
+                </a:solidFill>
+                <a:latin typeface="Calibri" pitchFamily="34" charset="0"/>
+                <a:ea typeface="Calibri" pitchFamily="34" charset="-122"/>
+                <a:cs typeface="Calibri" pitchFamily="34" charset="-120"/>
+              </a:rPr>
+              <a:t>RAC-2025-00055</a:t>
+            </a:r>
+            <a:endParaRPr lang="en-US" sz="1050" dirty="0"/>
+          </a:p>
+        </p:txBody>
+      </p:sp>
+      <p:sp>
+        <p:nvSpPr>
+          <p:cNvPr id="12" name="Text"/>
+          <p:cNvSpPr txBox="1"/>
+          <p:nvPr/>
+        </p:nvSpPr>
+        <p:spPr>
+          <a:xfrm>
+            <a:off x="796928" y="4900000"/>
+            <a:ext cx="5000655" cy="560000"/>
+          </a:xfrm>
+          <a:prstGeom prst="rect">
+            <a:avLst/>
+          </a:prstGeom>
+          <a:noFill/>
+          <a:ln/>
+        </p:spPr>
+        <p:txBody>
+          <a:bodyPr wrap="square" lIns="0" tIns="0" rIns="0" bIns="0" rtlCol="0" anchor="t"/>
+          <a:lstStyle/>
+          <a:p>
+            <a:pPr indent="0" marL="0">
+              <a:lnSpc>
+                <a:spcPct val="110000"/>
+              </a:lnSpc>
+              <a:buNone/>
+            </a:pPr>
+            <a:r>
+              <a:rPr lang="en-US" sz="1250" dirty="0">
+                <a:solidFill>
+                  <a:srgbClr val="16262E"/>
+                </a:solidFill>
+                <a:latin typeface="Calibri" pitchFamily="34" charset="0"/>
+                <a:ea typeface="Calibri" pitchFamily="34" charset="-122"/>
+                <a:cs typeface="Calibri" pitchFamily="34" charset="-120"/>
+              </a:rPr>
+              <a:t>Comparten tarjeta, quiere y saber. Una es de uso indebido y la otra de vigencia del plástico.</a:t>
+            </a:r>
+            <a:endParaRPr lang="en-US" sz="1250" dirty="0"/>
+          </a:p>
+        </p:txBody>
+      </p:sp>
+      <p:sp>
+        <p:nvSpPr>
+          <p:cNvPr id="13" name="Shape"/>
+          <p:cNvSpPr/>
+          <p:nvPr/>
+        </p:nvSpPr>
+        <p:spPr>
+          <a:xfrm>
+            <a:off x="6164511" y="1900000"/>
+            <a:ext cx="5460655" cy="3700000"/>
+          </a:xfrm>
+          <a:prstGeom prst="roundRect">
+            <a:avLst>
+              <a:gd name="adj" fmla="val 2933"/>
+            </a:avLst>
+          </a:prstGeom>
+          <a:solidFill>
+            <a:srgbClr val="D7E7E7"/>
+          </a:solidFill>
+          <a:ln w="12700">
+            <a:solidFill>
+              <a:srgbClr val="D7E7E7"/>
+            </a:solidFill>
+            <a:prstDash val="solid"/>
+          </a:ln>
+        </p:spPr>
+      </p:sp>
+      <p:sp>
+        <p:nvSpPr>
+          <p:cNvPr id="14" name="Text"/>
+          <p:cNvSpPr txBox="1"/>
+          <p:nvPr/>
+        </p:nvSpPr>
+        <p:spPr>
+          <a:xfrm>
+            <a:off x="6394511" y="2080000"/>
+            <a:ext cx="5000655" cy="330000"/>
+          </a:xfrm>
+          <a:prstGeom prst="rect">
+            <a:avLst/>
+          </a:prstGeom>
+          <a:noFill/>
+          <a:ln/>
+        </p:spPr>
+        <p:txBody>
+          <a:bodyPr wrap="square" lIns="0" tIns="0" rIns="0" bIns="0" rtlCol="0" anchor="t"/>
+          <a:lstStyle/>
+          <a:p>
+            <a:pPr indent="0" marL="0">
+              <a:buNone/>
+            </a:pPr>
+            <a:r>
+              <a:rPr lang="en-US" sz="1600" b="1" dirty="0">
+                <a:solidFill>
+                  <a:srgbClr val="2E7D7D"/>
+                </a:solidFill>
+                <a:latin typeface="Arial" pitchFamily="34" charset="0"/>
+                <a:ea typeface="Arial" pitchFamily="34" charset="-122"/>
+                <a:cs typeface="Arial" pitchFamily="34" charset="-120"/>
+              </a:rPr>
+              <a:t>Distintas palabras, mismo tema</a:t>
+            </a:r>
+            <a:endParaRPr lang="en-US" sz="1600" dirty="0"/>
+          </a:p>
+        </p:txBody>
+      </p:sp>
+      <p:sp>
+        <p:nvSpPr>
+          <p:cNvPr id="15" name="Shape"/>
+          <p:cNvSpPr/>
+          <p:nvPr/>
+        </p:nvSpPr>
+        <p:spPr>
+          <a:xfrm>
+            <a:off x="6394511" y="2440000"/>
+            <a:ext cx="5000000" cy="1160000"/>
+          </a:xfrm>
+          <a:prstGeom prst="roundRect">
+            <a:avLst>
+              <a:gd name="adj" fmla="val 8000"/>
+            </a:avLst>
+          </a:prstGeom>
+          <a:solidFill>
+            <a:srgbClr val="FFFFFF"/>
+          </a:solidFill>
+          <a:ln w="12700">
+            <a:solidFill>
+              <a:srgbClr val="FFFFFF"/>
+            </a:solidFill>
+            <a:prstDash val="solid"/>
+          </a:ln>
+        </p:spPr>
+      </p:sp>
+      <p:sp>
+        <p:nvSpPr>
+          <p:cNvPr id="16" name="Text"/>
+          <p:cNvSpPr txBox="1"/>
+          <p:nvPr/>
+        </p:nvSpPr>
+        <p:spPr>
+          <a:xfrm>
+            <a:off x="6634511" y="2560000"/>
+            <a:ext cx="4520000" cy="760000"/>
+          </a:xfrm>
+          <a:prstGeom prst="rect">
+            <a:avLst/>
+          </a:prstGeom>
+          <a:noFill/>
+          <a:ln/>
+        </p:spPr>
+        <p:txBody>
+          <a:bodyPr wrap="square" lIns="0" tIns="0" rIns="0" bIns="0" rtlCol="0" anchor="t"/>
+          <a:lstStyle/>
+          <a:p>
+            <a:pPr indent="0" marL="0">
+              <a:lnSpc>
+                <a:spcPct val="105000"/>
+              </a:lnSpc>
+              <a:buNone/>
+            </a:pPr>
+            <a:r>
+              <a:rPr lang="en-US" sz="1250" dirty="0">
+                <a:solidFill>
+                  <a:srgbClr val="16262E"/>
+                </a:solidFill>
+                <a:latin typeface="Calibri" pitchFamily="34" charset="0"/>
+                <a:ea typeface="Calibri" pitchFamily="34" charset="-122"/>
+                <a:cs typeface="Calibri" pitchFamily="34" charset="-120"/>
+              </a:rPr>
+              <a:t>«La beneficiaria señala que el apoyo del bimestre no le ha llegado. Comenta que a su vecina sí le depositaron desde la semana pasada.»</a:t>
+            </a:r>
+            <a:endParaRPr lang="en-US" sz="1250" dirty="0"/>
+          </a:p>
+        </p:txBody>
+      </p:sp>
+      <p:sp>
+        <p:nvSpPr>
+          <p:cNvPr id="17" name="Text"/>
+          <p:cNvSpPr txBox="1"/>
+          <p:nvPr/>
+        </p:nvSpPr>
+        <p:spPr>
+          <a:xfrm>
+            <a:off x="6634511" y="3320000"/>
+            <a:ext cx="4520000" cy="220000"/>
+          </a:xfrm>
+          <a:prstGeom prst="rect">
+            <a:avLst/>
+          </a:prstGeom>
+          <a:noFill/>
+          <a:ln/>
+        </p:spPr>
+        <p:txBody>
+          <a:bodyPr wrap="square" lIns="0" tIns="0" rIns="0" bIns="0" rtlCol="0" anchor="t"/>
+          <a:lstStyle/>
+          <a:p>
+            <a:pPr indent="0" marL="0">
+              <a:buNone/>
+            </a:pPr>
+            <a:r>
+              <a:rPr lang="en-US" sz="1050" dirty="0">
+                <a:solidFill>
+                  <a:srgbClr val="5A6B73"/>
+                </a:solidFill>
+                <a:latin typeface="Calibri" pitchFamily="34" charset="0"/>
+                <a:ea typeface="Calibri" pitchFamily="34" charset="-122"/>
+                <a:cs typeface="Calibri" pitchFamily="34" charset="-120"/>
+              </a:rPr>
+              <a:t>RAC-2025-00014</a:t>
+            </a:r>
+            <a:endParaRPr lang="en-US" sz="1050" dirty="0"/>
+          </a:p>
+        </p:txBody>
+      </p:sp>
+      <p:sp>
+        <p:nvSpPr>
+          <p:cNvPr id="18" name="Shape"/>
+          <p:cNvSpPr/>
+          <p:nvPr/>
+        </p:nvSpPr>
+        <p:spPr>
+          <a:xfrm>
+            <a:off x="6394511" y="3660000"/>
+            <a:ext cx="5000000" cy="1160000"/>
+          </a:xfrm>
+          <a:prstGeom prst="roundRect">
+            <a:avLst>
+              <a:gd name="adj" fmla="val 8000"/>
+            </a:avLst>
+          </a:prstGeom>
+          <a:solidFill>
+            <a:srgbClr val="FFFFFF"/>
+          </a:solidFill>
+          <a:ln w="12700">
+            <a:solidFill>
+              <a:srgbClr val="FFFFFF"/>
+            </a:solidFill>
+            <a:prstDash val="solid"/>
+          </a:ln>
+        </p:spPr>
+      </p:sp>
+      <p:sp>
+        <p:nvSpPr>
+          <p:cNvPr id="19" name="Text"/>
+          <p:cNvSpPr txBox="1"/>
+          <p:nvPr/>
+        </p:nvSpPr>
+        <p:spPr>
+          <a:xfrm>
+            <a:off x="6634511" y="3780000"/>
+            <a:ext cx="4520000" cy="760000"/>
+          </a:xfrm>
+          <a:prstGeom prst="rect">
+            <a:avLst/>
+          </a:prstGeom>
+          <a:noFill/>
+          <a:ln/>
+        </p:spPr>
+        <p:txBody>
+          <a:bodyPr wrap="square" lIns="0" tIns="0" rIns="0" bIns="0" rtlCol="0" anchor="t"/>
+          <a:lstStyle/>
+          <a:p>
+            <a:pPr indent="0" marL="0">
+              <a:lnSpc>
+                <a:spcPct val="105000"/>
+              </a:lnSpc>
+              <a:buNone/>
+            </a:pPr>
+            <a:r>
+              <a:rPr lang="en-US" sz="1250" dirty="0">
+                <a:solidFill>
+                  <a:srgbClr val="16262E"/>
+                </a:solidFill>
+                <a:latin typeface="Calibri" pitchFamily="34" charset="0"/>
+                <a:ea typeface="Calibri" pitchFamily="34" charset="-122"/>
+                <a:cs typeface="Calibri" pitchFamily="34" charset="-120"/>
+              </a:rPr>
+              <a:t>«No ha podido cobrar porque en el banco le dicen que su cuenta aparece inactiva.»</a:t>
+            </a:r>
+            <a:endParaRPr lang="en-US" sz="1250" dirty="0"/>
+          </a:p>
+        </p:txBody>
+      </p:sp>
+      <p:sp>
+        <p:nvSpPr>
+          <p:cNvPr id="20" name="Text"/>
+          <p:cNvSpPr txBox="1"/>
+          <p:nvPr/>
+        </p:nvSpPr>
+        <p:spPr>
+          <a:xfrm>
+            <a:off x="6634511" y="4540000"/>
+            <a:ext cx="4520000" cy="220000"/>
+          </a:xfrm>
+          <a:prstGeom prst="rect">
+            <a:avLst/>
+          </a:prstGeom>
+          <a:noFill/>
+          <a:ln/>
+        </p:spPr>
+        <p:txBody>
+          <a:bodyPr wrap="square" lIns="0" tIns="0" rIns="0" bIns="0" rtlCol="0" anchor="t"/>
+          <a:lstStyle/>
+          <a:p>
+            <a:pPr indent="0" marL="0">
+              <a:buNone/>
+            </a:pPr>
+            <a:r>
+              <a:rPr lang="en-US" sz="1050" dirty="0">
+                <a:solidFill>
+                  <a:srgbClr val="5A6B73"/>
+                </a:solidFill>
+                <a:latin typeface="Calibri" pitchFamily="34" charset="0"/>
+                <a:ea typeface="Calibri" pitchFamily="34" charset="-122"/>
+                <a:cs typeface="Calibri" pitchFamily="34" charset="-120"/>
+              </a:rPr>
+              <a:t>RAC-2025-00096</a:t>
+            </a:r>
+            <a:endParaRPr lang="en-US" sz="1050" dirty="0"/>
+          </a:p>
+        </p:txBody>
+      </p:sp>
+      <p:sp>
+        <p:nvSpPr>
+          <p:cNvPr id="21" name="Text"/>
+          <p:cNvSpPr txBox="1"/>
+          <p:nvPr/>
+        </p:nvSpPr>
+        <p:spPr>
+          <a:xfrm>
+            <a:off x="6394511" y="4900000"/>
+            <a:ext cx="5000655" cy="560000"/>
+          </a:xfrm>
+          <a:prstGeom prst="rect">
+            <a:avLst/>
+          </a:prstGeom>
+          <a:noFill/>
+          <a:ln/>
+        </p:spPr>
+        <p:txBody>
+          <a:bodyPr wrap="square" lIns="0" tIns="0" rIns="0" bIns="0" rtlCol="0" anchor="t"/>
+          <a:lstStyle/>
+          <a:p>
+            <a:pPr indent="0" marL="0">
+              <a:lnSpc>
+                <a:spcPct val="110000"/>
+              </a:lnSpc>
+              <a:buNone/>
+            </a:pPr>
+            <a:r>
+              <a:rPr lang="en-US" sz="1250" dirty="0">
+                <a:solidFill>
+                  <a:srgbClr val="16262E"/>
+                </a:solidFill>
+                <a:latin typeface="Calibri" pitchFamily="34" charset="0"/>
+                <a:ea typeface="Calibri" pitchFamily="34" charset="-122"/>
+                <a:cs typeface="Calibri" pitchFamily="34" charset="-120"/>
+              </a:rPr>
+              <a:t>No comparten una sola palabra de contenido. Las dos dicen lo mismo: no tengo mi dinero.</a:t>
+            </a:r>
+            <a:endParaRPr lang="en-US" sz="1250" dirty="0"/>
+          </a:p>
+        </p:txBody>
+      </p:sp>
+      <p:sp>
+        <p:nvSpPr>
+          <p:cNvPr id="22" name="Shape"/>
+          <p:cNvSpPr/>
+          <p:nvPr/>
+        </p:nvSpPr>
+        <p:spPr>
+          <a:xfrm>
+            <a:off x="566928" y="5824728"/>
+            <a:ext cx="11057839" cy="594360"/>
+          </a:xfrm>
+          <a:prstGeom prst="roundRect">
+            <a:avLst>
+              <a:gd name="adj" fmla="val 8235"/>
+            </a:avLst>
+          </a:prstGeom>
+          <a:solidFill>
+            <a:srgbClr val="F7E4D8"/>
+          </a:solidFill>
+          <a:ln w="12700">
+            <a:solidFill>
+              <a:srgbClr val="F7E4D8"/>
+            </a:solidFill>
+            <a:prstDash val="solid"/>
+          </a:ln>
+        </p:spPr>
+      </p:sp>
+      <p:sp>
+        <p:nvSpPr>
+          <p:cNvPr id="23" name="Text"/>
+          <p:cNvSpPr txBox="1"/>
+          <p:nvPr/>
+        </p:nvSpPr>
+        <p:spPr>
+          <a:xfrm>
+            <a:off x="804672" y="5824728"/>
+            <a:ext cx="10582351" cy="594360"/>
+          </a:xfrm>
+          <a:prstGeom prst="rect">
+            <a:avLst/>
+          </a:prstGeom>
+          <a:noFill/>
+          <a:ln/>
+        </p:spPr>
+        <p:txBody>
+          <a:bodyPr wrap="square" lIns="0" tIns="0" rIns="0" bIns="0" rtlCol="0" anchor="ctr"/>
+          <a:lstStyle/>
+          <a:p>
+            <a:pPr indent="0" marL="0">
+              <a:lnSpc>
+                <a:spcPct val="110000"/>
+              </a:lnSpc>
+              <a:buNone/>
+            </a:pPr>
+            <a:r>
+              <a:rPr lang="en-US" sz="1300" dirty="0">
+                <a:solidFill>
+                  <a:srgbClr val="16262E"/>
+                </a:solidFill>
+                <a:latin typeface="Calibri" pitchFamily="34" charset="0"/>
+                <a:ea typeface="Calibri" pitchFamily="34" charset="-122"/>
+                <a:cs typeface="Calibri" pitchFamily="34" charset="-120"/>
+              </a:rPr>
+              <a:t>Por eso las herramientas convierten el texto en coordenadas, los vectores: lo que significa parecido queda cerca aunque esté escrito distinto. Y cuando el dato no es texto sino una tabla de variables mezcladas, la distancia se mide con Gower, que verás en el Módulo III.</a:t>
+            </a:r>
+            <a:endParaRPr lang="en-US" sz="1300" dirty="0"/>
+          </a:p>
+        </p:txBody>
+      </p:sp>
+    </p:spTree>
+  </p:cSld>
+  <p:clrMapOvr>
+    <a:masterClrMapping/>
+  </p:clrMapOvr>
+</p:sld>
+</file>
+
+<file path=ppt/slides/slide2.xml><?xml version="1.0" encoding="utf-8"?>
+<p:sld xmlns:a="http://schemas.openxmlformats.org/drawingml/2006/main" xmlns:r="http://schemas.openxmlformats.org/officeDocument/2006/relationships" xmlns:p="http://schemas.openxmlformats.org/presentationml/2006/main">
+  <p:cSld name="Agenda">
+    <p:spTree>
+      <p:nvGrpSpPr>
+        <p:cNvPr id="1" name=""/>
+        <p:cNvGrpSpPr/>
+        <p:nvPr/>
+      </p:nvGrpSpPr>
+      <p:grpSpPr>
+        <a:xfrm>
+          <a:off x="0" y="0"/>
+          <a:ext cx="0" cy="0"/>
+          <a:chOff x="0" y="0"/>
+          <a:chExt cx="0" cy="0"/>
+        </a:xfrm>
+      </p:grpSpPr>
+      <p:sp>
+        <p:nvSpPr>
+          <p:cNvPr id="2" name="Text"/>
+          <p:cNvSpPr txBox="1"/>
+          <p:nvPr/>
+        </p:nvSpPr>
+        <p:spPr>
+          <a:xfrm>
+            <a:off x="566928" y="402336"/>
+            <a:ext cx="11057839" cy="749808"/>
+          </a:xfrm>
+          <a:prstGeom prst="rect">
+            <a:avLst/>
+          </a:prstGeom>
+          <a:noFill/>
+          <a:ln/>
+        </p:spPr>
+        <p:txBody>
+          <a:bodyPr wrap="square" lIns="0" tIns="0" rIns="0" bIns="0" rtlCol="0" anchor="t"/>
+          <a:lstStyle/>
+          <a:p>
+            <a:pPr algn="l" indent="0" marL="0">
+              <a:buNone/>
+            </a:pPr>
+            <a:r>
+              <a:rPr lang="en-US" sz="3200" b="1" dirty="0">
+                <a:solidFill>
+                  <a:srgbClr val="16262E"/>
+                </a:solidFill>
+                <a:latin typeface="Arial" pitchFamily="34" charset="0"/>
+                <a:ea typeface="Arial" pitchFamily="34" charset="-122"/>
+                <a:cs typeface="Arial" pitchFamily="34" charset="-120"/>
+              </a:rPr>
+              <a:t>Cómo vamos a usar los 150 minutos</a:t>
+            </a:r>
+            <a:endParaRPr lang="en-US" sz="3200" dirty="0"/>
+          </a:p>
+        </p:txBody>
+      </p:sp>
+      <p:sp>
+        <p:nvSpPr>
+          <p:cNvPr id="3" name="Shape"/>
+          <p:cNvSpPr/>
+          <p:nvPr/>
+        </p:nvSpPr>
+        <p:spPr>
+          <a:xfrm>
+            <a:off x="9485071" y="457200"/>
+            <a:ext cx="2139696" cy="347472"/>
+          </a:xfrm>
+          <a:prstGeom prst="roundRect">
+            <a:avLst>
+              <a:gd name="adj" fmla="val 50000"/>
             </a:avLst>
           </a:prstGeom>
           <a:solidFill>
@@ -6633,14 +8817,14 @@
       </p:sp>
       <p:sp>
         <p:nvSpPr>
-          <p:cNvPr id="6" name="Text 4"/>
-          <p:cNvSpPr txBox="1"/>
-          <p:nvPr/>
-        </p:nvSpPr>
-        <p:spPr>
-          <a:xfrm>
-            <a:off x="786384" y="1408176"/>
-            <a:ext cx="1371600" cy="1081278"/>
+          <p:cNvPr id="4" name="Text"/>
+          <p:cNvSpPr txBox="1"/>
+          <p:nvPr/>
+        </p:nvSpPr>
+        <p:spPr>
+          <a:xfrm>
+            <a:off x="9485071" y="457200"/>
+            <a:ext cx="2139696" cy="347472"/>
           </a:xfrm>
           <a:prstGeom prst="rect">
             <a:avLst/>
@@ -6652,80 +8836,38 @@
           <a:bodyPr wrap="square" lIns="0" tIns="0" rIns="0" bIns="0" rtlCol="0" anchor="ctr"/>
           <a:lstStyle/>
           <a:p>
-            <a:pPr indent="0" marL="0">
-              <a:buNone/>
-            </a:pPr>
-            <a:r>
-              <a:rPr lang="en-US" sz="1300" b="1" dirty="0">
-                <a:solidFill>
-                  <a:srgbClr val="2E7D7D"/>
-                </a:solidFill>
-                <a:latin typeface="Arial" pitchFamily="34" charset="0"/>
-                <a:ea typeface="Arial" pitchFamily="34" charset="-122"/>
-                <a:cs typeface="Arial" pitchFamily="34" charset="-120"/>
-              </a:rPr>
-              <a:t>9:00</a:t>
-            </a:r>
-            <a:endParaRPr lang="en-US" sz="1300" dirty="0"/>
-          </a:p>
-        </p:txBody>
-      </p:sp>
-      <p:sp>
-        <p:nvSpPr>
-          <p:cNvPr id="7" name="Text 5"/>
-          <p:cNvSpPr txBox="1"/>
-          <p:nvPr/>
-        </p:nvSpPr>
-        <p:spPr>
-          <a:xfrm>
-            <a:off x="2194560" y="1463040"/>
-            <a:ext cx="3517240" cy="971550"/>
-          </a:xfrm>
-          <a:prstGeom prst="rect">
-            <a:avLst/>
-          </a:prstGeom>
-          <a:noFill/>
-          <a:ln/>
-        </p:spPr>
-        <p:txBody>
-          <a:bodyPr wrap="square" lIns="0" tIns="0" rIns="0" bIns="0" rtlCol="0" anchor="ctr"/>
-          <a:lstStyle/>
-          <a:p>
-            <a:pPr indent="0" marL="0">
-              <a:lnSpc>
-                <a:spcPct val="105000"/>
-              </a:lnSpc>
-              <a:buNone/>
-            </a:pPr>
-            <a:r>
-              <a:rPr lang="en-US" sz="1350" dirty="0">
-                <a:solidFill>
-                  <a:srgbClr val="16262E"/>
+            <a:pPr algn="ctr" indent="0" marL="0">
+              <a:buNone/>
+            </a:pPr>
+            <a:r>
+              <a:rPr lang="en-US" sz="1200" b="1" dirty="0">
+                <a:solidFill>
+                  <a:srgbClr val="5A6B73"/>
                 </a:solidFill>
                 <a:latin typeface="Calibri" pitchFamily="34" charset="0"/>
                 <a:ea typeface="Calibri" pitchFamily="34" charset="-122"/>
                 <a:cs typeface="Calibri" pitchFamily="34" charset="-120"/>
               </a:rPr>
-              <a:t>Las cuatro tareas y para qué sirve cada una</a:t>
-            </a:r>
-            <a:endParaRPr lang="en-US" sz="1350" dirty="0"/>
-          </a:p>
-        </p:txBody>
-      </p:sp>
-      <p:sp>
-        <p:nvSpPr>
-          <p:cNvPr id="8" name="Shape 6"/>
+              <a:t>9:00 a 11:30</a:t>
+            </a:r>
+            <a:endParaRPr lang="en-US" sz="1200" dirty="0"/>
+          </a:p>
+        </p:txBody>
+      </p:sp>
+      <p:sp>
+        <p:nvSpPr>
+          <p:cNvPr id="5" name="Shape"/>
           <p:cNvSpPr/>
           <p:nvPr/>
         </p:nvSpPr>
         <p:spPr>
           <a:xfrm>
-            <a:off x="566928" y="2635758"/>
-            <a:ext cx="5364328" cy="1081278"/>
+            <a:off x="566928" y="1408176"/>
+            <a:ext cx="5364328" cy="860000"/>
           </a:xfrm>
           <a:prstGeom prst="roundRect">
             <a:avLst>
-              <a:gd name="adj" fmla="val 5920"/>
+              <a:gd name="adj" fmla="val 5000"/>
             </a:avLst>
           </a:prstGeom>
           <a:solidFill>
@@ -6741,14 +8883,14 @@
       </p:sp>
       <p:sp>
         <p:nvSpPr>
-          <p:cNvPr id="9" name="Text 7"/>
-          <p:cNvSpPr txBox="1"/>
-          <p:nvPr/>
-        </p:nvSpPr>
-        <p:spPr>
-          <a:xfrm>
-            <a:off x="786384" y="2635758"/>
-            <a:ext cx="1371600" cy="1081278"/>
+          <p:cNvPr id="6" name="Text"/>
+          <p:cNvSpPr txBox="1"/>
+          <p:nvPr/>
+        </p:nvSpPr>
+        <p:spPr>
+          <a:xfrm>
+            <a:off x="786384" y="1408176"/>
+            <a:ext cx="1371600" cy="860000"/>
           </a:xfrm>
           <a:prstGeom prst="rect">
             <a:avLst/>
@@ -6772,7 +8914,7 @@
                 <a:ea typeface="Arial" pitchFamily="34" charset="-122"/>
                 <a:cs typeface="Arial" pitchFamily="34" charset="-120"/>
               </a:rPr>
-              <a:t>9:25</a:t>
+              <a:t>9:00</a:t>
             </a:r>
             <a:endParaRPr lang="en-US" sz="1300" dirty="0"/>
           </a:p>
@@ -6780,14 +8922,14 @@
       </p:sp>
       <p:sp>
         <p:nvSpPr>
-          <p:cNvPr id="10" name="Text 8"/>
-          <p:cNvSpPr txBox="1"/>
-          <p:nvPr/>
-        </p:nvSpPr>
-        <p:spPr>
-          <a:xfrm>
-            <a:off x="2194560" y="2690622"/>
-            <a:ext cx="3517240" cy="971550"/>
+          <p:cNvPr id="7" name="Text"/>
+          <p:cNvSpPr txBox="1"/>
+          <p:nvPr/>
+        </p:nvSpPr>
+        <p:spPr>
+          <a:xfrm>
+            <a:off x="2194560" y="1448176"/>
+            <a:ext cx="3517240" cy="780000"/>
           </a:xfrm>
           <a:prstGeom prst="rect">
             <a:avLst/>
@@ -6801,12 +8943,12 @@
           <a:p>
             <a:pPr indent="0" marL="0">
               <a:lnSpc>
-                <a:spcPct val="105000"/>
+                <a:spcPct val="108000"/>
               </a:lnSpc>
               <a:buNone/>
             </a:pPr>
             <a:r>
-              <a:rPr lang="en-US" sz="1350" dirty="0">
+              <a:rPr lang="en-US" sz="1300" dirty="0">
                 <a:solidFill>
                   <a:srgbClr val="16262E"/>
                 </a:solidFill>
@@ -6814,26 +8956,26 @@
                 <a:ea typeface="Calibri" pitchFamily="34" charset="-122"/>
                 <a:cs typeface="Calibri" pitchFamily="34" charset="-120"/>
               </a:rPr>
-              <a:t>Práctica A: las dos formas de resumir</a:t>
-            </a:r>
-            <a:endParaRPr lang="en-US" sz="1350" dirty="0"/>
-          </a:p>
-        </p:txBody>
-      </p:sp>
-      <p:sp>
-        <p:nvSpPr>
-          <p:cNvPr id="11" name="Shape 9"/>
+              <a:t>Las cuatro tareas y para qué sirve cada una</a:t>
+            </a:r>
+            <a:endParaRPr lang="en-US" sz="1300" dirty="0"/>
+          </a:p>
+        </p:txBody>
+      </p:sp>
+      <p:sp>
+        <p:nvSpPr>
+          <p:cNvPr id="8" name="Shape"/>
           <p:cNvSpPr/>
           <p:nvPr/>
         </p:nvSpPr>
         <p:spPr>
           <a:xfrm>
-            <a:off x="566928" y="3863340"/>
-            <a:ext cx="5364328" cy="1081278"/>
+            <a:off x="566928" y="2341176"/>
+            <a:ext cx="5364328" cy="860000"/>
           </a:xfrm>
           <a:prstGeom prst="roundRect">
             <a:avLst>
-              <a:gd name="adj" fmla="val 5920"/>
+              <a:gd name="adj" fmla="val 5000"/>
             </a:avLst>
           </a:prstGeom>
           <a:solidFill>
@@ -6849,14 +8991,14 @@
       </p:sp>
       <p:sp>
         <p:nvSpPr>
-          <p:cNvPr id="12" name="Text 10"/>
-          <p:cNvSpPr txBox="1"/>
-          <p:nvPr/>
-        </p:nvSpPr>
-        <p:spPr>
-          <a:xfrm>
-            <a:off x="786384" y="3863340"/>
-            <a:ext cx="1371600" cy="1081278"/>
+          <p:cNvPr id="9" name="Text"/>
+          <p:cNvSpPr txBox="1"/>
+          <p:nvPr/>
+        </p:nvSpPr>
+        <p:spPr>
+          <a:xfrm>
+            <a:off x="786384" y="2341176"/>
+            <a:ext cx="1371600" cy="860000"/>
           </a:xfrm>
           <a:prstGeom prst="rect">
             <a:avLst/>
@@ -6880,7 +9022,7 @@
                 <a:ea typeface="Arial" pitchFamily="34" charset="-122"/>
                 <a:cs typeface="Arial" pitchFamily="34" charset="-120"/>
               </a:rPr>
-              <a:t>9:45</a:t>
+              <a:t>9:25</a:t>
             </a:r>
             <a:endParaRPr lang="en-US" sz="1300" dirty="0"/>
           </a:p>
@@ -6888,14 +9030,14 @@
       </p:sp>
       <p:sp>
         <p:nvSpPr>
-          <p:cNvPr id="13" name="Text 11"/>
-          <p:cNvSpPr txBox="1"/>
-          <p:nvPr/>
-        </p:nvSpPr>
-        <p:spPr>
-          <a:xfrm>
-            <a:off x="2194560" y="3918204"/>
-            <a:ext cx="3517240" cy="971550"/>
+          <p:cNvPr id="10" name="Text"/>
+          <p:cNvSpPr txBox="1"/>
+          <p:nvPr/>
+        </p:nvSpPr>
+        <p:spPr>
+          <a:xfrm>
+            <a:off x="2194560" y="2381176"/>
+            <a:ext cx="3517240" cy="780000"/>
           </a:xfrm>
           <a:prstGeom prst="rect">
             <a:avLst/>
@@ -6909,12 +9051,12 @@
           <a:p>
             <a:pPr indent="0" marL="0">
               <a:lnSpc>
-                <a:spcPct val="105000"/>
+                <a:spcPct val="108000"/>
               </a:lnSpc>
               <a:buNone/>
             </a:pPr>
             <a:r>
-              <a:rPr lang="en-US" sz="1350" dirty="0">
+              <a:rPr lang="en-US" sz="1300" dirty="0">
                 <a:solidFill>
                   <a:srgbClr val="16262E"/>
                 </a:solidFill>
@@ -6922,26 +9064,242 @@
                 <a:ea typeface="Calibri" pitchFamily="34" charset="-122"/>
                 <a:cs typeface="Calibri" pitchFamily="34" charset="-120"/>
               </a:rPr>
-              <a:t>Práctica B: sacar la tabla de adentro del texto</a:t>
-            </a:r>
-            <a:endParaRPr lang="en-US" sz="1350" dirty="0"/>
-          </a:p>
-        </p:txBody>
-      </p:sp>
-      <p:sp>
-        <p:nvSpPr>
-          <p:cNvPr id="14" name="Shape 12"/>
+              <a:t>Práctica A: las dos formas de resumir</a:t>
+            </a:r>
+            <a:endParaRPr lang="en-US" sz="1300" dirty="0"/>
+          </a:p>
+        </p:txBody>
+      </p:sp>
+      <p:sp>
+        <p:nvSpPr>
+          <p:cNvPr id="11" name="Shape"/>
           <p:cNvSpPr/>
           <p:nvPr/>
         </p:nvSpPr>
         <p:spPr>
           <a:xfrm>
-            <a:off x="566928" y="5090922"/>
-            <a:ext cx="5364328" cy="1081278"/>
+            <a:off x="566928" y="3274176"/>
+            <a:ext cx="5364328" cy="860000"/>
           </a:xfrm>
           <a:prstGeom prst="roundRect">
             <a:avLst>
-              <a:gd name="adj" fmla="val 5920"/>
+              <a:gd name="adj" fmla="val 5000"/>
+            </a:avLst>
+          </a:prstGeom>
+          <a:solidFill>
+            <a:srgbClr val="F2F5F6"/>
+          </a:solidFill>
+          <a:ln w="12700">
+            <a:solidFill>
+              <a:srgbClr val="F2F5F6"/>
+            </a:solidFill>
+            <a:prstDash val="solid"/>
+          </a:ln>
+        </p:spPr>
+      </p:sp>
+      <p:sp>
+        <p:nvSpPr>
+          <p:cNvPr id="12" name="Text"/>
+          <p:cNvSpPr txBox="1"/>
+          <p:nvPr/>
+        </p:nvSpPr>
+        <p:spPr>
+          <a:xfrm>
+            <a:off x="786384" y="3274176"/>
+            <a:ext cx="1371600" cy="860000"/>
+          </a:xfrm>
+          <a:prstGeom prst="rect">
+            <a:avLst/>
+          </a:prstGeom>
+          <a:noFill/>
+          <a:ln/>
+        </p:spPr>
+        <p:txBody>
+          <a:bodyPr wrap="square" lIns="0" tIns="0" rIns="0" bIns="0" rtlCol="0" anchor="ctr"/>
+          <a:lstStyle/>
+          <a:p>
+            <a:pPr indent="0" marL="0">
+              <a:buNone/>
+            </a:pPr>
+            <a:r>
+              <a:rPr lang="en-US" sz="1300" b="1" dirty="0">
+                <a:solidFill>
+                  <a:srgbClr val="2E7D7D"/>
+                </a:solidFill>
+                <a:latin typeface="Arial" pitchFamily="34" charset="0"/>
+                <a:ea typeface="Arial" pitchFamily="34" charset="-122"/>
+                <a:cs typeface="Arial" pitchFamily="34" charset="-120"/>
+              </a:rPr>
+              <a:t>9:37</a:t>
+            </a:r>
+            <a:endParaRPr lang="en-US" sz="1300" dirty="0"/>
+          </a:p>
+        </p:txBody>
+      </p:sp>
+      <p:sp>
+        <p:nvSpPr>
+          <p:cNvPr id="13" name="Text"/>
+          <p:cNvSpPr txBox="1"/>
+          <p:nvPr/>
+        </p:nvSpPr>
+        <p:spPr>
+          <a:xfrm>
+            <a:off x="2194560" y="3314176"/>
+            <a:ext cx="3517240" cy="780000"/>
+          </a:xfrm>
+          <a:prstGeom prst="rect">
+            <a:avLst/>
+          </a:prstGeom>
+          <a:noFill/>
+          <a:ln/>
+        </p:spPr>
+        <p:txBody>
+          <a:bodyPr wrap="square" lIns="0" tIns="0" rIns="0" bIns="0" rtlCol="0" anchor="ctr"/>
+          <a:lstStyle/>
+          <a:p>
+            <a:pPr indent="0" marL="0">
+              <a:lnSpc>
+                <a:spcPct val="108000"/>
+              </a:lnSpc>
+              <a:buNone/>
+            </a:pPr>
+            <a:r>
+              <a:rPr lang="en-US" sz="1300" dirty="0">
+                <a:solidFill>
+                  <a:srgbClr val="16262E"/>
+                </a:solidFill>
+                <a:latin typeface="Calibri" pitchFamily="34" charset="0"/>
+                <a:ea typeface="Calibri" pitchFamily="34" charset="-122"/>
+                <a:cs typeface="Calibri" pitchFamily="34" charset="-120"/>
+              </a:rPr>
+              <a:t>Práctica B: sacar la tabla de adentro del texto</a:t>
+            </a:r>
+            <a:endParaRPr lang="en-US" sz="1300" dirty="0"/>
+          </a:p>
+        </p:txBody>
+      </p:sp>
+      <p:sp>
+        <p:nvSpPr>
+          <p:cNvPr id="14" name="Shape"/>
+          <p:cNvSpPr/>
+          <p:nvPr/>
+        </p:nvSpPr>
+        <p:spPr>
+          <a:xfrm>
+            <a:off x="566928" y="4207176"/>
+            <a:ext cx="5364328" cy="860000"/>
+          </a:xfrm>
+          <a:prstGeom prst="roundRect">
+            <a:avLst>
+              <a:gd name="adj" fmla="val 5000"/>
+            </a:avLst>
+          </a:prstGeom>
+          <a:solidFill>
+            <a:srgbClr val="F2F5F6"/>
+          </a:solidFill>
+          <a:ln w="12700">
+            <a:solidFill>
+              <a:srgbClr val="F2F5F6"/>
+            </a:solidFill>
+            <a:prstDash val="solid"/>
+          </a:ln>
+        </p:spPr>
+      </p:sp>
+      <p:sp>
+        <p:nvSpPr>
+          <p:cNvPr id="15" name="Text"/>
+          <p:cNvSpPr txBox="1"/>
+          <p:nvPr/>
+        </p:nvSpPr>
+        <p:spPr>
+          <a:xfrm>
+            <a:off x="786384" y="4207176"/>
+            <a:ext cx="1371600" cy="860000"/>
+          </a:xfrm>
+          <a:prstGeom prst="rect">
+            <a:avLst/>
+          </a:prstGeom>
+          <a:noFill/>
+          <a:ln/>
+        </p:spPr>
+        <p:txBody>
+          <a:bodyPr wrap="square" lIns="0" tIns="0" rIns="0" bIns="0" rtlCol="0" anchor="ctr"/>
+          <a:lstStyle/>
+          <a:p>
+            <a:pPr indent="0" marL="0">
+              <a:buNone/>
+            </a:pPr>
+            <a:r>
+              <a:rPr lang="en-US" sz="1300" b="1" dirty="0">
+                <a:solidFill>
+                  <a:srgbClr val="2E7D7D"/>
+                </a:solidFill>
+                <a:latin typeface="Arial" pitchFamily="34" charset="0"/>
+                <a:ea typeface="Arial" pitchFamily="34" charset="-122"/>
+                <a:cs typeface="Arial" pitchFamily="34" charset="-120"/>
+              </a:rPr>
+              <a:t>10:07</a:t>
+            </a:r>
+            <a:endParaRPr lang="en-US" sz="1300" dirty="0"/>
+          </a:p>
+        </p:txBody>
+      </p:sp>
+      <p:sp>
+        <p:nvSpPr>
+          <p:cNvPr id="16" name="Text"/>
+          <p:cNvSpPr txBox="1"/>
+          <p:nvPr/>
+        </p:nvSpPr>
+        <p:spPr>
+          <a:xfrm>
+            <a:off x="2194560" y="4247176"/>
+            <a:ext cx="3517240" cy="780000"/>
+          </a:xfrm>
+          <a:prstGeom prst="rect">
+            <a:avLst/>
+          </a:prstGeom>
+          <a:noFill/>
+          <a:ln/>
+        </p:spPr>
+        <p:txBody>
+          <a:bodyPr wrap="square" lIns="0" tIns="0" rIns="0" bIns="0" rtlCol="0" anchor="ctr"/>
+          <a:lstStyle/>
+          <a:p>
+            <a:pPr indent="0" marL="0">
+              <a:lnSpc>
+                <a:spcPct val="108000"/>
+              </a:lnSpc>
+              <a:buNone/>
+            </a:pPr>
+            <a:r>
+              <a:rPr lang="en-US" sz="1300" dirty="0">
+                <a:solidFill>
+                  <a:srgbClr val="16262E"/>
+                </a:solidFill>
+                <a:latin typeface="Calibri" pitchFamily="34" charset="0"/>
+                <a:ea typeface="Calibri" pitchFamily="34" charset="-122"/>
+                <a:cs typeface="Calibri" pitchFamily="34" charset="-120"/>
+              </a:rPr>
+              <a:t>Cómo decide la máquina que dos textos se parecen</a:t>
+            </a:r>
+            <a:endParaRPr lang="en-US" sz="1300" dirty="0"/>
+          </a:p>
+        </p:txBody>
+      </p:sp>
+      <p:sp>
+        <p:nvSpPr>
+          <p:cNvPr id="17" name="Shape"/>
+          <p:cNvSpPr/>
+          <p:nvPr/>
+        </p:nvSpPr>
+        <p:spPr>
+          <a:xfrm>
+            <a:off x="566928" y="5140176"/>
+            <a:ext cx="5364328" cy="860000"/>
+          </a:xfrm>
+          <a:prstGeom prst="roundRect">
+            <a:avLst>
+              <a:gd name="adj" fmla="val 5000"/>
             </a:avLst>
           </a:prstGeom>
           <a:solidFill>
@@ -6957,14 +9315,14 @@
       </p:sp>
       <p:sp>
         <p:nvSpPr>
-          <p:cNvPr id="15" name="Text 13"/>
-          <p:cNvSpPr txBox="1"/>
-          <p:nvPr/>
-        </p:nvSpPr>
-        <p:spPr>
-          <a:xfrm>
-            <a:off x="786384" y="5090922"/>
-            <a:ext cx="1371600" cy="1081278"/>
+          <p:cNvPr id="18" name="Text"/>
+          <p:cNvSpPr txBox="1"/>
+          <p:nvPr/>
+        </p:nvSpPr>
+        <p:spPr>
+          <a:xfrm>
+            <a:off x="786384" y="5140176"/>
+            <a:ext cx="1371600" cy="860000"/>
           </a:xfrm>
           <a:prstGeom prst="rect">
             <a:avLst/>
@@ -6988,7 +9346,7 @@
                 <a:ea typeface="Arial" pitchFamily="34" charset="-122"/>
                 <a:cs typeface="Arial" pitchFamily="34" charset="-120"/>
               </a:rPr>
-              <a:t>10:15</a:t>
+              <a:t>10:19</a:t>
             </a:r>
             <a:endParaRPr lang="en-US" sz="1300" dirty="0"/>
           </a:p>
@@ -6996,14 +9354,14 @@
       </p:sp>
       <p:sp>
         <p:nvSpPr>
-          <p:cNvPr id="16" name="Text 14"/>
-          <p:cNvSpPr txBox="1"/>
-          <p:nvPr/>
-        </p:nvSpPr>
-        <p:spPr>
-          <a:xfrm>
-            <a:off x="2194560" y="5145786"/>
-            <a:ext cx="3517240" cy="971550"/>
+          <p:cNvPr id="19" name="Text"/>
+          <p:cNvSpPr txBox="1"/>
+          <p:nvPr/>
+        </p:nvSpPr>
+        <p:spPr>
+          <a:xfrm>
+            <a:off x="2194560" y="5180176"/>
+            <a:ext cx="3517240" cy="780000"/>
           </a:xfrm>
           <a:prstGeom prst="rect">
             <a:avLst/>
@@ -7017,12 +9375,12 @@
           <a:p>
             <a:pPr indent="0" marL="0">
               <a:lnSpc>
-                <a:spcPct val="105000"/>
+                <a:spcPct val="108000"/>
               </a:lnSpc>
               <a:buNone/>
             </a:pPr>
             <a:r>
-              <a:rPr lang="en-US" sz="1350" dirty="0">
+              <a:rPr lang="en-US" sz="1300" dirty="0">
                 <a:solidFill>
                   <a:srgbClr val="16262E"/>
                 </a:solidFill>
@@ -7030,26 +9388,26 @@
                 <a:ea typeface="Calibri" pitchFamily="34" charset="-122"/>
                 <a:cs typeface="Calibri" pitchFamily="34" charset="-120"/>
               </a:rPr>
-              <a:t>Receso de diez minutos</a:t>
-            </a:r>
-            <a:endParaRPr lang="en-US" sz="1350" dirty="0"/>
-          </a:p>
-        </p:txBody>
-      </p:sp>
-      <p:sp>
-        <p:nvSpPr>
-          <p:cNvPr id="17" name="Shape 15"/>
+              <a:t>Receso, con charla opcional sobre vectores</a:t>
+            </a:r>
+            <a:endParaRPr lang="en-US" sz="1300" dirty="0"/>
+          </a:p>
+        </p:txBody>
+      </p:sp>
+      <p:sp>
+        <p:nvSpPr>
+          <p:cNvPr id="20" name="Shape"/>
           <p:cNvSpPr/>
           <p:nvPr/>
         </p:nvSpPr>
         <p:spPr>
           <a:xfrm>
             <a:off x="6260440" y="1408176"/>
-            <a:ext cx="5364328" cy="1081278"/>
+            <a:ext cx="5364328" cy="860000"/>
           </a:xfrm>
           <a:prstGeom prst="roundRect">
             <a:avLst>
-              <a:gd name="adj" fmla="val 5920"/>
+              <a:gd name="adj" fmla="val 5000"/>
             </a:avLst>
           </a:prstGeom>
           <a:solidFill>
@@ -7065,14 +9423,14 @@
       </p:sp>
       <p:sp>
         <p:nvSpPr>
-          <p:cNvPr id="18" name="Text 16"/>
+          <p:cNvPr id="21" name="Text"/>
           <p:cNvSpPr txBox="1"/>
           <p:nvPr/>
         </p:nvSpPr>
         <p:spPr>
           <a:xfrm>
             <a:off x="6479896" y="1408176"/>
-            <a:ext cx="1371600" cy="1081278"/>
+            <a:ext cx="1371600" cy="860000"/>
           </a:xfrm>
           <a:prstGeom prst="rect">
             <a:avLst/>
@@ -7096,7 +9454,7 @@
                 <a:ea typeface="Arial" pitchFamily="34" charset="-122"/>
                 <a:cs typeface="Arial" pitchFamily="34" charset="-120"/>
               </a:rPr>
-              <a:t>10:25</a:t>
+              <a:t>10:29</a:t>
             </a:r>
             <a:endParaRPr lang="en-US" sz="1300" dirty="0"/>
           </a:p>
@@ -7104,14 +9462,14 @@
       </p:sp>
       <p:sp>
         <p:nvSpPr>
-          <p:cNvPr id="19" name="Text 17"/>
-          <p:cNvSpPr txBox="1"/>
-          <p:nvPr/>
-        </p:nvSpPr>
-        <p:spPr>
-          <a:xfrm>
-            <a:off x="7888072" y="1463040"/>
-            <a:ext cx="3517240" cy="971550"/>
+          <p:cNvPr id="22" name="Text"/>
+          <p:cNvSpPr txBox="1"/>
+          <p:nvPr/>
+        </p:nvSpPr>
+        <p:spPr>
+          <a:xfrm>
+            <a:off x="7888072" y="1448176"/>
+            <a:ext cx="3517240" cy="780000"/>
           </a:xfrm>
           <a:prstGeom prst="rect">
             <a:avLst/>
@@ -7125,12 +9483,12 @@
           <a:p>
             <a:pPr indent="0" marL="0">
               <a:lnSpc>
-                <a:spcPct val="105000"/>
+                <a:spcPct val="108000"/>
               </a:lnSpc>
               <a:buNone/>
             </a:pPr>
             <a:r>
-              <a:rPr lang="en-US" sz="1350" dirty="0">
+              <a:rPr lang="en-US" sz="1300" dirty="0">
                 <a:solidFill>
                   <a:srgbClr val="16262E"/>
                 </a:solidFill>
@@ -7140,24 +9498,24 @@
               </a:rPr>
               <a:t>Práctica C: agrupar temas sin perder a la minoría</a:t>
             </a:r>
-            <a:endParaRPr lang="en-US" sz="1350" dirty="0"/>
-          </a:p>
-        </p:txBody>
-      </p:sp>
-      <p:sp>
-        <p:nvSpPr>
-          <p:cNvPr id="20" name="Shape 18"/>
+            <a:endParaRPr lang="en-US" sz="1300" dirty="0"/>
+          </a:p>
+        </p:txBody>
+      </p:sp>
+      <p:sp>
+        <p:nvSpPr>
+          <p:cNvPr id="23" name="Shape"/>
           <p:cNvSpPr/>
           <p:nvPr/>
         </p:nvSpPr>
         <p:spPr>
           <a:xfrm>
-            <a:off x="6260440" y="2635758"/>
-            <a:ext cx="5364328" cy="1081278"/>
+            <a:off x="6260440" y="2341176"/>
+            <a:ext cx="5364328" cy="860000"/>
           </a:xfrm>
           <a:prstGeom prst="roundRect">
             <a:avLst>
-              <a:gd name="adj" fmla="val 5920"/>
+              <a:gd name="adj" fmla="val 5000"/>
             </a:avLst>
           </a:prstGeom>
           <a:solidFill>
@@ -7173,14 +9531,14 @@
       </p:sp>
       <p:sp>
         <p:nvSpPr>
-          <p:cNvPr id="21" name="Text 19"/>
-          <p:cNvSpPr txBox="1"/>
-          <p:nvPr/>
-        </p:nvSpPr>
-        <p:spPr>
-          <a:xfrm>
-            <a:off x="6479896" y="2635758"/>
-            <a:ext cx="1371600" cy="1081278"/>
+          <p:cNvPr id="24" name="Text"/>
+          <p:cNvSpPr txBox="1"/>
+          <p:nvPr/>
+        </p:nvSpPr>
+        <p:spPr>
+          <a:xfrm>
+            <a:off x="6479896" y="2341176"/>
+            <a:ext cx="1371600" cy="860000"/>
           </a:xfrm>
           <a:prstGeom prst="rect">
             <a:avLst/>
@@ -7204,7 +9562,7 @@
                 <a:ea typeface="Arial" pitchFamily="34" charset="-122"/>
                 <a:cs typeface="Arial" pitchFamily="34" charset="-120"/>
               </a:rPr>
-              <a:t>11:00</a:t>
+              <a:t>11:04</a:t>
             </a:r>
             <a:endParaRPr lang="en-US" sz="1300" dirty="0"/>
           </a:p>
@@ -7212,14 +9570,14 @@
       </p:sp>
       <p:sp>
         <p:nvSpPr>
-          <p:cNvPr id="22" name="Text 20"/>
-          <p:cNvSpPr txBox="1"/>
-          <p:nvPr/>
-        </p:nvSpPr>
-        <p:spPr>
-          <a:xfrm>
-            <a:off x="7888072" y="2690622"/>
-            <a:ext cx="3517240" cy="971550"/>
+          <p:cNvPr id="25" name="Text"/>
+          <p:cNvSpPr txBox="1"/>
+          <p:nvPr/>
+        </p:nvSpPr>
+        <p:spPr>
+          <a:xfrm>
+            <a:off x="7888072" y="2381176"/>
+            <a:ext cx="3517240" cy="780000"/>
           </a:xfrm>
           <a:prstGeom prst="rect">
             <a:avLst/>
@@ -7233,12 +9591,12 @@
           <a:p>
             <a:pPr indent="0" marL="0">
               <a:lnSpc>
-                <a:spcPct val="105000"/>
+                <a:spcPct val="108000"/>
               </a:lnSpc>
               <a:buNone/>
             </a:pPr>
             <a:r>
-              <a:rPr lang="en-US" sz="1350" dirty="0">
+              <a:rPr lang="en-US" sz="1300" dirty="0">
                 <a:solidFill>
                   <a:srgbClr val="16262E"/>
                 </a:solidFill>
@@ -7248,24 +9606,24 @@
               </a:rPr>
               <a:t>Práctica D: postura y causa raíz</a:t>
             </a:r>
-            <a:endParaRPr lang="en-US" sz="1350" dirty="0"/>
-          </a:p>
-        </p:txBody>
-      </p:sp>
-      <p:sp>
-        <p:nvSpPr>
-          <p:cNvPr id="23" name="Shape 21"/>
+            <a:endParaRPr lang="en-US" sz="1300" dirty="0"/>
+          </a:p>
+        </p:txBody>
+      </p:sp>
+      <p:sp>
+        <p:nvSpPr>
+          <p:cNvPr id="26" name="Shape"/>
           <p:cNvSpPr/>
           <p:nvPr/>
         </p:nvSpPr>
         <p:spPr>
           <a:xfrm>
-            <a:off x="6260440" y="3863340"/>
-            <a:ext cx="5364328" cy="1081278"/>
+            <a:off x="6260440" y="3274176"/>
+            <a:ext cx="5364328" cy="860000"/>
           </a:xfrm>
           <a:prstGeom prst="roundRect">
             <a:avLst>
-              <a:gd name="adj" fmla="val 5920"/>
+              <a:gd name="adj" fmla="val 5000"/>
             </a:avLst>
           </a:prstGeom>
           <a:solidFill>
@@ -7281,14 +9639,14 @@
       </p:sp>
       <p:sp>
         <p:nvSpPr>
-          <p:cNvPr id="24" name="Text 22"/>
-          <p:cNvSpPr txBox="1"/>
-          <p:nvPr/>
-        </p:nvSpPr>
-        <p:spPr>
-          <a:xfrm>
-            <a:off x="6479896" y="3863340"/>
-            <a:ext cx="1371600" cy="1081278"/>
+          <p:cNvPr id="27" name="Text"/>
+          <p:cNvSpPr txBox="1"/>
+          <p:nvPr/>
+        </p:nvSpPr>
+        <p:spPr>
+          <a:xfrm>
+            <a:off x="6479896" y="3274176"/>
+            <a:ext cx="1371600" cy="860000"/>
           </a:xfrm>
           <a:prstGeom prst="rect">
             <a:avLst/>
@@ -7312,7 +9670,7 @@
                 <a:ea typeface="Arial" pitchFamily="34" charset="-122"/>
                 <a:cs typeface="Arial" pitchFamily="34" charset="-120"/>
               </a:rPr>
-              <a:t>11:15</a:t>
+              <a:t>11:19</a:t>
             </a:r>
             <a:endParaRPr lang="en-US" sz="1300" dirty="0"/>
           </a:p>
@@ -7320,14 +9678,14 @@
       </p:sp>
       <p:sp>
         <p:nvSpPr>
-          <p:cNvPr id="25" name="Text 23"/>
-          <p:cNvSpPr txBox="1"/>
-          <p:nvPr/>
-        </p:nvSpPr>
-        <p:spPr>
-          <a:xfrm>
-            <a:off x="7888072" y="3918204"/>
-            <a:ext cx="3517240" cy="971550"/>
+          <p:cNvPr id="28" name="Text"/>
+          <p:cNvSpPr txBox="1"/>
+          <p:nvPr/>
+        </p:nvSpPr>
+        <p:spPr>
+          <a:xfrm>
+            <a:off x="7888072" y="3314176"/>
+            <a:ext cx="3517240" cy="780000"/>
           </a:xfrm>
           <a:prstGeom prst="rect">
             <a:avLst/>
@@ -7341,12 +9699,12 @@
           <a:p>
             <a:pPr indent="0" marL="0">
               <a:lnSpc>
-                <a:spcPct val="105000"/>
+                <a:spcPct val="108000"/>
               </a:lnSpc>
               <a:buNone/>
             </a:pPr>
             <a:r>
-              <a:rPr lang="en-US" sz="1350" dirty="0">
+              <a:rPr lang="en-US" sz="1300" dirty="0">
                 <a:solidFill>
                   <a:srgbClr val="16262E"/>
                 </a:solidFill>
@@ -7356,24 +9714,24 @@
               </a:rPr>
               <a:t>Qué haces cuando el texto no cabe</a:t>
             </a:r>
-            <a:endParaRPr lang="en-US" sz="1350" dirty="0"/>
-          </a:p>
-        </p:txBody>
-      </p:sp>
-      <p:sp>
-        <p:nvSpPr>
-          <p:cNvPr id="26" name="Shape 24"/>
+            <a:endParaRPr lang="en-US" sz="1300" dirty="0"/>
+          </a:p>
+        </p:txBody>
+      </p:sp>
+      <p:sp>
+        <p:nvSpPr>
+          <p:cNvPr id="29" name="Shape"/>
           <p:cNvSpPr/>
           <p:nvPr/>
         </p:nvSpPr>
         <p:spPr>
           <a:xfrm>
-            <a:off x="6260440" y="5090922"/>
-            <a:ext cx="5364328" cy="1081278"/>
+            <a:off x="6260440" y="4207176"/>
+            <a:ext cx="5364328" cy="860000"/>
           </a:xfrm>
           <a:prstGeom prst="roundRect">
             <a:avLst>
-              <a:gd name="adj" fmla="val 5920"/>
+              <a:gd name="adj" fmla="val 5000"/>
             </a:avLst>
           </a:prstGeom>
           <a:solidFill>
@@ -7389,14 +9747,14 @@
       </p:sp>
       <p:sp>
         <p:nvSpPr>
-          <p:cNvPr id="27" name="Text 25"/>
-          <p:cNvSpPr txBox="1"/>
-          <p:nvPr/>
-        </p:nvSpPr>
-        <p:spPr>
-          <a:xfrm>
-            <a:off x="6479896" y="5090922"/>
-            <a:ext cx="1371600" cy="1081278"/>
+          <p:cNvPr id="30" name="Text"/>
+          <p:cNvSpPr txBox="1"/>
+          <p:nvPr/>
+        </p:nvSpPr>
+        <p:spPr>
+          <a:xfrm>
+            <a:off x="6479896" y="4207176"/>
+            <a:ext cx="1371600" cy="860000"/>
           </a:xfrm>
           <a:prstGeom prst="rect">
             <a:avLst/>
@@ -7420,7 +9778,7 @@
                 <a:ea typeface="Arial" pitchFamily="34" charset="-122"/>
                 <a:cs typeface="Arial" pitchFamily="34" charset="-120"/>
               </a:rPr>
-              <a:t>11:25</a:t>
+              <a:t>11:27</a:t>
             </a:r>
             <a:endParaRPr lang="en-US" sz="1300" dirty="0"/>
           </a:p>
@@ -7428,14 +9786,14 @@
       </p:sp>
       <p:sp>
         <p:nvSpPr>
-          <p:cNvPr id="28" name="Text 26"/>
-          <p:cNvSpPr txBox="1"/>
-          <p:nvPr/>
-        </p:nvSpPr>
-        <p:spPr>
-          <a:xfrm>
-            <a:off x="7888072" y="5145786"/>
-            <a:ext cx="3517240" cy="971550"/>
+          <p:cNvPr id="31" name="Text"/>
+          <p:cNvSpPr txBox="1"/>
+          <p:nvPr/>
+        </p:nvSpPr>
+        <p:spPr>
+          <a:xfrm>
+            <a:off x="7888072" y="4247176"/>
+            <a:ext cx="3517240" cy="780000"/>
           </a:xfrm>
           <a:prstGeom prst="rect">
             <a:avLst/>
@@ -7449,12 +9807,12 @@
           <a:p>
             <a:pPr indent="0" marL="0">
               <a:lnSpc>
-                <a:spcPct val="105000"/>
+                <a:spcPct val="108000"/>
               </a:lnSpc>
               <a:buNone/>
             </a:pPr>
             <a:r>
-              <a:rPr lang="en-US" sz="1350" dirty="0">
+              <a:rPr lang="en-US" sz="1300" dirty="0">
                 <a:solidFill>
                   <a:srgbClr val="16262E"/>
                 </a:solidFill>
@@ -7464,13 +9822,13 @@
               </a:rPr>
               <a:t>Cierre y entregables</a:t>
             </a:r>
-            <a:endParaRPr lang="en-US" sz="1350" dirty="0"/>
-          </a:p>
-        </p:txBody>
-      </p:sp>
-      <p:sp>
-        <p:nvSpPr>
-          <p:cNvPr id="29" name="Text 27"/>
+            <a:endParaRPr lang="en-US" sz="1300" dirty="0"/>
+          </a:p>
+        </p:txBody>
+      </p:sp>
+      <p:sp>
+        <p:nvSpPr>
+          <p:cNvPr id="32" name="Text"/>
           <p:cNvSpPr txBox="1"/>
           <p:nvPr/>
         </p:nvSpPr>
@@ -7486,7 +9844,7 @@
           <a:ln/>
         </p:spPr>
         <p:txBody>
-          <a:bodyPr wrap="square" lIns="0" tIns="0" rIns="0" bIns="0" rtlCol="0" anchor="ctr"/>
+          <a:bodyPr wrap="square" lIns="0" tIns="0" rIns="0" bIns="0" rtlCol="0" anchor="t"/>
           <a:lstStyle/>
           <a:p>
             <a:pPr indent="0" marL="0">
@@ -7501,7 +9859,7 @@
                 <a:ea typeface="Calibri" pitchFamily="34" charset="-122"/>
                 <a:cs typeface="Calibri" pitchFamily="34" charset="-120"/>
               </a:rPr>
-              <a:t>Hoy trabajas 90 minutos con las manos en el teclado. Es la sesión con más práctica de las dos semanas.</a:t>
+              <a:t>Hoy trabajas unos 90 minutos con las manos en el teclado. Es la sesión con más práctica de las dos semanas.</a:t>
             </a:r>
             <a:endParaRPr lang="en-US" sz="1000" dirty="0"/>
           </a:p>
@@ -9302,7 +11660,7 @@
                 <a:ea typeface="Arial" pitchFamily="34" charset="-122"/>
                 <a:cs typeface="Arial" pitchFamily="34" charset="-120"/>
               </a:rPr>
-              <a:t>20 minutos</a:t>
+              <a:t>12 minutos</a:t>
             </a:r>
             <a:endParaRPr lang="en-US" sz="1300" dirty="0"/>
           </a:p>
@@ -9740,7 +12098,7 @@
                 <a:ea typeface="Calibri" pitchFamily="34" charset="-122"/>
                 <a:cs typeface="Calibri" pitchFamily="34" charset="-120"/>
               </a:rPr>
-              <a:t>Pon las dos salidas lado a lado y busca una afirmación que esté en la abstractiva pero no se sostenga en ninguna oración de la extractiva.</a:t>
+              <a:t>Ponlas lado a lado y busca una sola cosa: una afirmación de la abstractiva que no se sostenga en ninguna oración de la extractiva.</a:t>
             </a:r>
             <a:endParaRPr lang="en-US" sz="1450" dirty="0"/>
           </a:p>
@@ -11341,7 +13699,7 @@
                 <a:ea typeface="Calibri" pitchFamily="34" charset="-122"/>
                 <a:cs typeface="Calibri" pitchFamily="34" charset="-120"/>
               </a:rPr>
-              <a:t>10:25 a 11:00</a:t>
+              <a:t>10:29 a 11:04</a:t>
             </a:r>
             <a:endParaRPr lang="en-US" sz="1200" dirty="0"/>
           </a:p>

</xml_diff>